<commit_message>
SODOTO pitch: mark what is demo, not deployed, or a use case
Marc's edits. Slide 4: a learner may ask to be shown again, and attests to understanding. Slide 8 is marked not accurate, demo only; slide 9 retitled to local trading economies; slide 10 marked not deployed; slide 11 marked a use case.

Co-Authored-By: Claude Opus 5.5 <noreply@anthropic.com>
</commit_message>
<xml_diff>
--- a/docs/sodoto-pitch.pptx
+++ b/docs/sodoto-pitch.pptx
@@ -5,23 +5,23 @@
     <p:sldMasterId id="2147483648" r:id="rId1"/>
   </p:sldMasterIdLst>
   <p:sldIdLst>
-    <p:sldId id="256" r:id="rId7"/>
-    <p:sldId id="257" r:id="rId8"/>
-    <p:sldId id="258" r:id="rId9"/>
-    <p:sldId id="259" r:id="rId10"/>
-    <p:sldId id="260" r:id="rId11"/>
-    <p:sldId id="261" r:id="rId12"/>
-    <p:sldId id="262" r:id="rId13"/>
-    <p:sldId id="263" r:id="rId14"/>
-    <p:sldId id="264" r:id="rId15"/>
-    <p:sldId id="265" r:id="rId16"/>
-    <p:sldId id="266" r:id="rId17"/>
-    <p:sldId id="267" r:id="rId18"/>
-    <p:sldId id="268" r:id="rId19"/>
-    <p:sldId id="269" r:id="rId20"/>
-    <p:sldId id="270" r:id="rId21"/>
+    <p:sldId id="256" r:id="rId2"/>
+    <p:sldId id="257" r:id="rId3"/>
+    <p:sldId id="258" r:id="rId4"/>
+    <p:sldId id="259" r:id="rId5"/>
+    <p:sldId id="260" r:id="rId6"/>
+    <p:sldId id="261" r:id="rId7"/>
+    <p:sldId id="262" r:id="rId8"/>
+    <p:sldId id="263" r:id="rId9"/>
+    <p:sldId id="264" r:id="rId10"/>
+    <p:sldId id="265" r:id="rId11"/>
+    <p:sldId id="266" r:id="rId12"/>
+    <p:sldId id="267" r:id="rId13"/>
+    <p:sldId id="268" r:id="rId14"/>
+    <p:sldId id="269" r:id="rId15"/>
+    <p:sldId id="270" r:id="rId16"/>
   </p:sldIdLst>
-  <p:sldSz cx="12188952" cy="6858000" type="screen4x3"/>
+  <p:sldSz cx="12188825" cy="6858000"/>
   <p:notesSz cx="6858000" cy="9144000"/>
   <p:defaultTextStyle>
     <a:defPPr>
@@ -118,6 +118,22 @@
       </a:defRPr>
     </a:lvl9pPr>
   </p:defaultTextStyle>
+  <p:extLst>
+    <p:ext uri="{EFAFB233-063F-42B5-8137-9DF3F51BA10A}">
+      <p15:sldGuideLst xmlns:p15="http://schemas.microsoft.com/office/powerpoint/2012/main">
+        <p15:guide id="1" orient="horz" pos="2160">
+          <p15:clr>
+            <a:srgbClr val="A4A3A4"/>
+          </p15:clr>
+        </p15:guide>
+        <p15:guide id="2" pos="2880">
+          <p15:clr>
+            <a:srgbClr val="A4A3A4"/>
+          </p15:clr>
+        </p15:guide>
+      </p15:sldGuideLst>
+    </p:ext>
+  </p:extLst>
 </p:presentation>
 </file>
 
@@ -159,10 +175,9 @@
           <a:lstStyle/>
           <a:p>
             <a:r>
-              <a:rPr lang="en-US" smtClean="0"/>
+              <a:rPr lang="en-US"/>
               <a:t>Click to edit Master title style</a:t>
             </a:r>
-            <a:endParaRPr lang="en-US"/>
           </a:p>
         </p:txBody>
       </p:sp>
@@ -278,10 +293,9 @@
           </a:lstStyle>
           <a:p>
             <a:r>
-              <a:rPr lang="en-US" smtClean="0"/>
+              <a:rPr lang="en-US"/>
               <a:t>Click to edit Master subtitle style</a:t>
             </a:r>
-            <a:endParaRPr lang="en-US"/>
           </a:p>
         </p:txBody>
       </p:sp>
@@ -302,7 +316,7 @@
           <a:p>
             <a:fld id="{5BCAD085-E8A6-8845-BD4E-CB4CCA059FC4}" type="datetimeFigureOut">
               <a:rPr lang="en-US" smtClean="0"/>
-              <a:t>1/27/13</a:t>
+              <a:t>9/26/26</a:t>
             </a:fld>
             <a:endParaRPr lang="en-US"/>
           </a:p>
@@ -396,10 +410,9 @@
           <a:lstStyle/>
           <a:p>
             <a:r>
-              <a:rPr lang="en-US" smtClean="0"/>
+              <a:rPr lang="en-US"/>
               <a:t>Click to edit Master title style</a:t>
             </a:r>
-            <a:endParaRPr lang="en-US"/>
           </a:p>
         </p:txBody>
       </p:sp>
@@ -420,38 +433,37 @@
           <a:p>
             <a:pPr lvl="0"/>
             <a:r>
-              <a:rPr lang="en-US" smtClean="0"/>
+              <a:rPr lang="en-US"/>
               <a:t>Click to edit Master text styles</a:t>
             </a:r>
           </a:p>
           <a:p>
             <a:pPr lvl="1"/>
             <a:r>
-              <a:rPr lang="en-US" smtClean="0"/>
+              <a:rPr lang="en-US"/>
               <a:t>Second level</a:t>
             </a:r>
           </a:p>
           <a:p>
             <a:pPr lvl="2"/>
             <a:r>
-              <a:rPr lang="en-US" smtClean="0"/>
+              <a:rPr lang="en-US"/>
               <a:t>Third level</a:t>
             </a:r>
           </a:p>
           <a:p>
             <a:pPr lvl="3"/>
             <a:r>
-              <a:rPr lang="en-US" smtClean="0"/>
+              <a:rPr lang="en-US"/>
               <a:t>Fourth level</a:t>
             </a:r>
           </a:p>
           <a:p>
             <a:pPr lvl="4"/>
             <a:r>
-              <a:rPr lang="en-US" smtClean="0"/>
+              <a:rPr lang="en-US"/>
               <a:t>Fifth level</a:t>
             </a:r>
-            <a:endParaRPr lang="en-US"/>
           </a:p>
         </p:txBody>
       </p:sp>
@@ -472,7 +484,7 @@
           <a:p>
             <a:fld id="{5BCAD085-E8A6-8845-BD4E-CB4CCA059FC4}" type="datetimeFigureOut">
               <a:rPr lang="en-US" smtClean="0"/>
-              <a:t>1/27/13</a:t>
+              <a:t>9/26/26</a:t>
             </a:fld>
             <a:endParaRPr lang="en-US"/>
           </a:p>
@@ -571,10 +583,9 @@
           <a:lstStyle/>
           <a:p>
             <a:r>
-              <a:rPr lang="en-US" smtClean="0"/>
+              <a:rPr lang="en-US"/>
               <a:t>Click to edit Master title style</a:t>
             </a:r>
-            <a:endParaRPr lang="en-US"/>
           </a:p>
         </p:txBody>
       </p:sp>
@@ -600,38 +611,37 @@
           <a:p>
             <a:pPr lvl="0"/>
             <a:r>
-              <a:rPr lang="en-US" smtClean="0"/>
+              <a:rPr lang="en-US"/>
               <a:t>Click to edit Master text styles</a:t>
             </a:r>
           </a:p>
           <a:p>
             <a:pPr lvl="1"/>
             <a:r>
-              <a:rPr lang="en-US" smtClean="0"/>
+              <a:rPr lang="en-US"/>
               <a:t>Second level</a:t>
             </a:r>
           </a:p>
           <a:p>
             <a:pPr lvl="2"/>
             <a:r>
-              <a:rPr lang="en-US" smtClean="0"/>
+              <a:rPr lang="en-US"/>
               <a:t>Third level</a:t>
             </a:r>
           </a:p>
           <a:p>
             <a:pPr lvl="3"/>
             <a:r>
-              <a:rPr lang="en-US" smtClean="0"/>
+              <a:rPr lang="en-US"/>
               <a:t>Fourth level</a:t>
             </a:r>
           </a:p>
           <a:p>
             <a:pPr lvl="4"/>
             <a:r>
-              <a:rPr lang="en-US" smtClean="0"/>
+              <a:rPr lang="en-US"/>
               <a:t>Fifth level</a:t>
             </a:r>
-            <a:endParaRPr lang="en-US"/>
           </a:p>
         </p:txBody>
       </p:sp>
@@ -652,7 +662,7 @@
           <a:p>
             <a:fld id="{5BCAD085-E8A6-8845-BD4E-CB4CCA059FC4}" type="datetimeFigureOut">
               <a:rPr lang="en-US" smtClean="0"/>
-              <a:t>1/27/13</a:t>
+              <a:t>9/26/26</a:t>
             </a:fld>
             <a:endParaRPr lang="en-US"/>
           </a:p>
@@ -746,10 +756,9 @@
           <a:lstStyle/>
           <a:p>
             <a:r>
-              <a:rPr lang="en-US" smtClean="0"/>
+              <a:rPr lang="en-US"/>
               <a:t>Click to edit Master title style</a:t>
             </a:r>
-            <a:endParaRPr lang="en-US"/>
           </a:p>
         </p:txBody>
       </p:sp>
@@ -770,38 +779,37 @@
           <a:p>
             <a:pPr lvl="0"/>
             <a:r>
-              <a:rPr lang="en-US" smtClean="0"/>
+              <a:rPr lang="en-US"/>
               <a:t>Click to edit Master text styles</a:t>
             </a:r>
           </a:p>
           <a:p>
             <a:pPr lvl="1"/>
             <a:r>
-              <a:rPr lang="en-US" smtClean="0"/>
+              <a:rPr lang="en-US"/>
               <a:t>Second level</a:t>
             </a:r>
           </a:p>
           <a:p>
             <a:pPr lvl="2"/>
             <a:r>
-              <a:rPr lang="en-US" smtClean="0"/>
+              <a:rPr lang="en-US"/>
               <a:t>Third level</a:t>
             </a:r>
           </a:p>
           <a:p>
             <a:pPr lvl="3"/>
             <a:r>
-              <a:rPr lang="en-US" smtClean="0"/>
+              <a:rPr lang="en-US"/>
               <a:t>Fourth level</a:t>
             </a:r>
           </a:p>
           <a:p>
             <a:pPr lvl="4"/>
             <a:r>
-              <a:rPr lang="en-US" smtClean="0"/>
+              <a:rPr lang="en-US"/>
               <a:t>Fifth level</a:t>
             </a:r>
-            <a:endParaRPr lang="en-US"/>
           </a:p>
         </p:txBody>
       </p:sp>
@@ -822,7 +830,7 @@
           <a:p>
             <a:fld id="{5BCAD085-E8A6-8845-BD4E-CB4CCA059FC4}" type="datetimeFigureOut">
               <a:rPr lang="en-US" smtClean="0"/>
-              <a:t>1/27/13</a:t>
+              <a:t>9/26/26</a:t>
             </a:fld>
             <a:endParaRPr lang="en-US"/>
           </a:p>
@@ -925,10 +933,9 @@
           </a:lstStyle>
           <a:p>
             <a:r>
-              <a:rPr lang="en-US" smtClean="0"/>
+              <a:rPr lang="en-US"/>
               <a:t>Click to edit Master title style</a:t>
             </a:r>
-            <a:endParaRPr lang="en-US"/>
           </a:p>
         </p:txBody>
       </p:sp>
@@ -1045,7 +1052,7 @@
           <a:p>
             <a:pPr lvl="0"/>
             <a:r>
-              <a:rPr lang="en-US" smtClean="0"/>
+              <a:rPr lang="en-US"/>
               <a:t>Click to edit Master text styles</a:t>
             </a:r>
           </a:p>
@@ -1068,7 +1075,7 @@
           <a:p>
             <a:fld id="{5BCAD085-E8A6-8845-BD4E-CB4CCA059FC4}" type="datetimeFigureOut">
               <a:rPr lang="en-US" smtClean="0"/>
-              <a:t>1/27/13</a:t>
+              <a:t>9/26/26</a:t>
             </a:fld>
             <a:endParaRPr lang="en-US"/>
           </a:p>
@@ -1162,10 +1169,9 @@
           <a:lstStyle/>
           <a:p>
             <a:r>
-              <a:rPr lang="en-US" smtClean="0"/>
+              <a:rPr lang="en-US"/>
               <a:t>Click to edit Master title style</a:t>
             </a:r>
-            <a:endParaRPr lang="en-US"/>
           </a:p>
         </p:txBody>
       </p:sp>
@@ -1219,38 +1225,37 @@
           <a:p>
             <a:pPr lvl="0"/>
             <a:r>
-              <a:rPr lang="en-US" smtClean="0"/>
+              <a:rPr lang="en-US"/>
               <a:t>Click to edit Master text styles</a:t>
             </a:r>
           </a:p>
           <a:p>
             <a:pPr lvl="1"/>
             <a:r>
-              <a:rPr lang="en-US" smtClean="0"/>
+              <a:rPr lang="en-US"/>
               <a:t>Second level</a:t>
             </a:r>
           </a:p>
           <a:p>
             <a:pPr lvl="2"/>
             <a:r>
-              <a:rPr lang="en-US" smtClean="0"/>
+              <a:rPr lang="en-US"/>
               <a:t>Third level</a:t>
             </a:r>
           </a:p>
           <a:p>
             <a:pPr lvl="3"/>
             <a:r>
-              <a:rPr lang="en-US" smtClean="0"/>
+              <a:rPr lang="en-US"/>
               <a:t>Fourth level</a:t>
             </a:r>
           </a:p>
           <a:p>
             <a:pPr lvl="4"/>
             <a:r>
-              <a:rPr lang="en-US" smtClean="0"/>
+              <a:rPr lang="en-US"/>
               <a:t>Fifth level</a:t>
             </a:r>
-            <a:endParaRPr lang="en-US"/>
           </a:p>
         </p:txBody>
       </p:sp>
@@ -1304,38 +1309,37 @@
           <a:p>
             <a:pPr lvl="0"/>
             <a:r>
-              <a:rPr lang="en-US" smtClean="0"/>
+              <a:rPr lang="en-US"/>
               <a:t>Click to edit Master text styles</a:t>
             </a:r>
           </a:p>
           <a:p>
             <a:pPr lvl="1"/>
             <a:r>
-              <a:rPr lang="en-US" smtClean="0"/>
+              <a:rPr lang="en-US"/>
               <a:t>Second level</a:t>
             </a:r>
           </a:p>
           <a:p>
             <a:pPr lvl="2"/>
             <a:r>
-              <a:rPr lang="en-US" smtClean="0"/>
+              <a:rPr lang="en-US"/>
               <a:t>Third level</a:t>
             </a:r>
           </a:p>
           <a:p>
             <a:pPr lvl="3"/>
             <a:r>
-              <a:rPr lang="en-US" smtClean="0"/>
+              <a:rPr lang="en-US"/>
               <a:t>Fourth level</a:t>
             </a:r>
           </a:p>
           <a:p>
             <a:pPr lvl="4"/>
             <a:r>
-              <a:rPr lang="en-US" smtClean="0"/>
+              <a:rPr lang="en-US"/>
               <a:t>Fifth level</a:t>
             </a:r>
-            <a:endParaRPr lang="en-US"/>
           </a:p>
         </p:txBody>
       </p:sp>
@@ -1356,7 +1360,7 @@
           <a:p>
             <a:fld id="{5BCAD085-E8A6-8845-BD4E-CB4CCA059FC4}" type="datetimeFigureOut">
               <a:rPr lang="en-US" smtClean="0"/>
-              <a:t>1/27/13</a:t>
+              <a:t>9/26/26</a:t>
             </a:fld>
             <a:endParaRPr lang="en-US"/>
           </a:p>
@@ -1454,10 +1458,9 @@
           </a:lstStyle>
           <a:p>
             <a:r>
-              <a:rPr lang="en-US" smtClean="0"/>
+              <a:rPr lang="en-US"/>
               <a:t>Click to edit Master title style</a:t>
             </a:r>
-            <a:endParaRPr lang="en-US"/>
           </a:p>
         </p:txBody>
       </p:sp>
@@ -1520,7 +1523,7 @@
           <a:p>
             <a:pPr lvl="0"/>
             <a:r>
-              <a:rPr lang="en-US" smtClean="0"/>
+              <a:rPr lang="en-US"/>
               <a:t>Click to edit Master text styles</a:t>
             </a:r>
           </a:p>
@@ -1576,38 +1579,37 @@
           <a:p>
             <a:pPr lvl="0"/>
             <a:r>
-              <a:rPr lang="en-US" smtClean="0"/>
+              <a:rPr lang="en-US"/>
               <a:t>Click to edit Master text styles</a:t>
             </a:r>
           </a:p>
           <a:p>
             <a:pPr lvl="1"/>
             <a:r>
-              <a:rPr lang="en-US" smtClean="0"/>
+              <a:rPr lang="en-US"/>
               <a:t>Second level</a:t>
             </a:r>
           </a:p>
           <a:p>
             <a:pPr lvl="2"/>
             <a:r>
-              <a:rPr lang="en-US" smtClean="0"/>
+              <a:rPr lang="en-US"/>
               <a:t>Third level</a:t>
             </a:r>
           </a:p>
           <a:p>
             <a:pPr lvl="3"/>
             <a:r>
-              <a:rPr lang="en-US" smtClean="0"/>
+              <a:rPr lang="en-US"/>
               <a:t>Fourth level</a:t>
             </a:r>
           </a:p>
           <a:p>
             <a:pPr lvl="4"/>
             <a:r>
-              <a:rPr lang="en-US" smtClean="0"/>
+              <a:rPr lang="en-US"/>
               <a:t>Fifth level</a:t>
             </a:r>
-            <a:endParaRPr lang="en-US"/>
           </a:p>
         </p:txBody>
       </p:sp>
@@ -1670,7 +1672,7 @@
           <a:p>
             <a:pPr lvl="0"/>
             <a:r>
-              <a:rPr lang="en-US" smtClean="0"/>
+              <a:rPr lang="en-US"/>
               <a:t>Click to edit Master text styles</a:t>
             </a:r>
           </a:p>
@@ -1726,38 +1728,37 @@
           <a:p>
             <a:pPr lvl="0"/>
             <a:r>
-              <a:rPr lang="en-US" smtClean="0"/>
+              <a:rPr lang="en-US"/>
               <a:t>Click to edit Master text styles</a:t>
             </a:r>
           </a:p>
           <a:p>
             <a:pPr lvl="1"/>
             <a:r>
-              <a:rPr lang="en-US" smtClean="0"/>
+              <a:rPr lang="en-US"/>
               <a:t>Second level</a:t>
             </a:r>
           </a:p>
           <a:p>
             <a:pPr lvl="2"/>
             <a:r>
-              <a:rPr lang="en-US" smtClean="0"/>
+              <a:rPr lang="en-US"/>
               <a:t>Third level</a:t>
             </a:r>
           </a:p>
           <a:p>
             <a:pPr lvl="3"/>
             <a:r>
-              <a:rPr lang="en-US" smtClean="0"/>
+              <a:rPr lang="en-US"/>
               <a:t>Fourth level</a:t>
             </a:r>
           </a:p>
           <a:p>
             <a:pPr lvl="4"/>
             <a:r>
-              <a:rPr lang="en-US" smtClean="0"/>
+              <a:rPr lang="en-US"/>
               <a:t>Fifth level</a:t>
             </a:r>
-            <a:endParaRPr lang="en-US"/>
           </a:p>
         </p:txBody>
       </p:sp>
@@ -1778,7 +1779,7 @@
           <a:p>
             <a:fld id="{5BCAD085-E8A6-8845-BD4E-CB4CCA059FC4}" type="datetimeFigureOut">
               <a:rPr lang="en-US" smtClean="0"/>
-              <a:t>1/27/13</a:t>
+              <a:t>9/26/26</a:t>
             </a:fld>
             <a:endParaRPr lang="en-US"/>
           </a:p>
@@ -1872,10 +1873,9 @@
           <a:lstStyle/>
           <a:p>
             <a:r>
-              <a:rPr lang="en-US" smtClean="0"/>
+              <a:rPr lang="en-US"/>
               <a:t>Click to edit Master title style</a:t>
             </a:r>
-            <a:endParaRPr lang="en-US"/>
           </a:p>
         </p:txBody>
       </p:sp>
@@ -1896,7 +1896,7 @@
           <a:p>
             <a:fld id="{5BCAD085-E8A6-8845-BD4E-CB4CCA059FC4}" type="datetimeFigureOut">
               <a:rPr lang="en-US" smtClean="0"/>
-              <a:t>1/27/13</a:t>
+              <a:t>9/26/26</a:t>
             </a:fld>
             <a:endParaRPr lang="en-US"/>
           </a:p>
@@ -1991,7 +1991,7 @@
           <a:p>
             <a:fld id="{5BCAD085-E8A6-8845-BD4E-CB4CCA059FC4}" type="datetimeFigureOut">
               <a:rPr lang="en-US" smtClean="0"/>
-              <a:t>1/27/13</a:t>
+              <a:t>9/25/26</a:t>
             </a:fld>
             <a:endParaRPr lang="en-US"/>
           </a:p>
@@ -2094,10 +2094,9 @@
           </a:lstStyle>
           <a:p>
             <a:r>
-              <a:rPr lang="en-US" smtClean="0"/>
+              <a:rPr lang="en-US"/>
               <a:t>Click to edit Master title style</a:t>
             </a:r>
-            <a:endParaRPr lang="en-US"/>
           </a:p>
         </p:txBody>
       </p:sp>
@@ -2151,38 +2150,37 @@
           <a:p>
             <a:pPr lvl="0"/>
             <a:r>
-              <a:rPr lang="en-US" smtClean="0"/>
+              <a:rPr lang="en-US"/>
               <a:t>Click to edit Master text styles</a:t>
             </a:r>
           </a:p>
           <a:p>
             <a:pPr lvl="1"/>
             <a:r>
-              <a:rPr lang="en-US" smtClean="0"/>
+              <a:rPr lang="en-US"/>
               <a:t>Second level</a:t>
             </a:r>
           </a:p>
           <a:p>
             <a:pPr lvl="2"/>
             <a:r>
-              <a:rPr lang="en-US" smtClean="0"/>
+              <a:rPr lang="en-US"/>
               <a:t>Third level</a:t>
             </a:r>
           </a:p>
           <a:p>
             <a:pPr lvl="3"/>
             <a:r>
-              <a:rPr lang="en-US" smtClean="0"/>
+              <a:rPr lang="en-US"/>
               <a:t>Fourth level</a:t>
             </a:r>
           </a:p>
           <a:p>
             <a:pPr lvl="4"/>
             <a:r>
-              <a:rPr lang="en-US" smtClean="0"/>
+              <a:rPr lang="en-US"/>
               <a:t>Fifth level</a:t>
             </a:r>
-            <a:endParaRPr lang="en-US"/>
           </a:p>
         </p:txBody>
       </p:sp>
@@ -2245,7 +2243,7 @@
           <a:p>
             <a:pPr lvl="0"/>
             <a:r>
-              <a:rPr lang="en-US" smtClean="0"/>
+              <a:rPr lang="en-US"/>
               <a:t>Click to edit Master text styles</a:t>
             </a:r>
           </a:p>
@@ -2268,7 +2266,7 @@
           <a:p>
             <a:fld id="{5BCAD085-E8A6-8845-BD4E-CB4CCA059FC4}" type="datetimeFigureOut">
               <a:rPr lang="en-US" smtClean="0"/>
-              <a:t>1/27/13</a:t>
+              <a:t>9/26/26</a:t>
             </a:fld>
             <a:endParaRPr lang="en-US"/>
           </a:p>
@@ -2371,10 +2369,9 @@
           </a:lstStyle>
           <a:p>
             <a:r>
-              <a:rPr lang="en-US" smtClean="0"/>
+              <a:rPr lang="en-US"/>
               <a:t>Click to edit Master title style</a:t>
             </a:r>
-            <a:endParaRPr lang="en-US"/>
           </a:p>
         </p:txBody>
       </p:sp>
@@ -2498,7 +2495,7 @@
           <a:p>
             <a:pPr lvl="0"/>
             <a:r>
-              <a:rPr lang="en-US" smtClean="0"/>
+              <a:rPr lang="en-US"/>
               <a:t>Click to edit Master text styles</a:t>
             </a:r>
           </a:p>
@@ -2521,7 +2518,7 @@
           <a:p>
             <a:fld id="{5BCAD085-E8A6-8845-BD4E-CB4CCA059FC4}" type="datetimeFigureOut">
               <a:rPr lang="en-US" smtClean="0"/>
-              <a:t>1/27/13</a:t>
+              <a:t>9/26/26</a:t>
             </a:fld>
             <a:endParaRPr lang="en-US"/>
           </a:p>
@@ -2630,10 +2627,9 @@
           <a:lstStyle/>
           <a:p>
             <a:r>
-              <a:rPr lang="en-US" smtClean="0"/>
+              <a:rPr lang="en-US"/>
               <a:t>Click to edit Master title style</a:t>
             </a:r>
-            <a:endParaRPr lang="en-US"/>
           </a:p>
         </p:txBody>
       </p:sp>
@@ -2664,38 +2660,37 @@
           <a:p>
             <a:pPr lvl="0"/>
             <a:r>
-              <a:rPr lang="en-US" smtClean="0"/>
+              <a:rPr lang="en-US"/>
               <a:t>Click to edit Master text styles</a:t>
             </a:r>
           </a:p>
           <a:p>
             <a:pPr lvl="1"/>
             <a:r>
-              <a:rPr lang="en-US" smtClean="0"/>
+              <a:rPr lang="en-US"/>
               <a:t>Second level</a:t>
             </a:r>
           </a:p>
           <a:p>
             <a:pPr lvl="2"/>
             <a:r>
-              <a:rPr lang="en-US" smtClean="0"/>
+              <a:rPr lang="en-US"/>
               <a:t>Third level</a:t>
             </a:r>
           </a:p>
           <a:p>
             <a:pPr lvl="3"/>
             <a:r>
-              <a:rPr lang="en-US" smtClean="0"/>
+              <a:rPr lang="en-US"/>
               <a:t>Fourth level</a:t>
             </a:r>
           </a:p>
           <a:p>
             <a:pPr lvl="4"/>
             <a:r>
-              <a:rPr lang="en-US" smtClean="0"/>
+              <a:rPr lang="en-US"/>
               <a:t>Fifth level</a:t>
             </a:r>
-            <a:endParaRPr lang="en-US"/>
           </a:p>
         </p:txBody>
       </p:sp>
@@ -2734,7 +2729,7 @@
           <a:p>
             <a:fld id="{5BCAD085-E8A6-8845-BD4E-CB4CCA059FC4}" type="datetimeFigureOut">
               <a:rPr lang="en-US" smtClean="0"/>
-              <a:t>1/27/13</a:t>
+              <a:t>9/25/26</a:t>
             </a:fld>
             <a:endParaRPr lang="en-US"/>
           </a:p>
@@ -3093,7 +3088,7 @@
 </file>
 
 <file path=ppt/slides/slide1.xml><?xml version="1.0" encoding="utf-8"?>
-<p:sld xmlns:a="http://schemas.openxmlformats.org/drawingml/2006/main" xmlns:p="http://schemas.openxmlformats.org/presentationml/2006/main" xmlns:r="http://schemas.openxmlformats.org/officeDocument/2006/relationships">
+<p:sld xmlns:a="http://schemas.openxmlformats.org/drawingml/2006/main" xmlns:r="http://schemas.openxmlformats.org/officeDocument/2006/relationships" xmlns:p="http://schemas.openxmlformats.org/presentationml/2006/main">
   <p:cSld>
     <p:bg>
       <p:bgPr>
@@ -3109,7 +3104,14 @@
         <p:cNvGrpSpPr/>
         <p:nvPr/>
       </p:nvGrpSpPr>
-      <p:grpSpPr/>
+      <p:grpSpPr>
+        <a:xfrm>
+          <a:off x="0" y="0"/>
+          <a:ext cx="0" cy="0"/>
+          <a:chOff x="0" y="0"/>
+          <a:chExt cx="0" cy="0"/>
+        </a:xfrm>
+      </p:grpSpPr>
       <p:sp>
         <p:nvSpPr>
           <p:cNvPr id="2" name="TextBox 1"/>
@@ -3185,6 +3187,7 @@
           <a:lstStyle/>
           <a:p>
             <a:pPr algn="ctr"/>
+            <a:endParaRPr/>
           </a:p>
         </p:txBody>
       </p:sp>
@@ -3267,7 +3270,7 @@
 </file>
 
 <file path=ppt/slides/slide10.xml><?xml version="1.0" encoding="utf-8"?>
-<p:sld xmlns:a="http://schemas.openxmlformats.org/drawingml/2006/main" xmlns:p="http://schemas.openxmlformats.org/presentationml/2006/main" xmlns:r="http://schemas.openxmlformats.org/officeDocument/2006/relationships">
+<p:sld xmlns:a="http://schemas.openxmlformats.org/drawingml/2006/main" xmlns:r="http://schemas.openxmlformats.org/officeDocument/2006/relationships" xmlns:p="http://schemas.openxmlformats.org/presentationml/2006/main">
   <p:cSld>
     <p:bg>
       <p:bgPr>
@@ -3283,7 +3286,14 @@
         <p:cNvGrpSpPr/>
         <p:nvPr/>
       </p:nvGrpSpPr>
-      <p:grpSpPr/>
+      <p:grpSpPr>
+        <a:xfrm>
+          <a:off x="0" y="0"/>
+          <a:ext cx="0" cy="0"/>
+          <a:chOff x="0" y="0"/>
+          <a:chExt cx="0" cy="0"/>
+        </a:xfrm>
+      </p:grpSpPr>
       <p:sp>
         <p:nvSpPr>
           <p:cNvPr id="2" name="TextBox 1"/>
@@ -3359,6 +3369,7 @@
           <a:lstStyle/>
           <a:p>
             <a:pPr algn="ctr"/>
+            <a:endParaRPr/>
           </a:p>
         </p:txBody>
       </p:sp>
@@ -3371,7 +3382,7 @@
         <p:spPr>
           <a:xfrm>
             <a:off x="411480" y="566928"/>
-            <a:ext cx="11338560" cy="1188720"/>
+            <a:ext cx="11338560" cy="1015663"/>
           </a:xfrm>
           <a:prstGeom prst="rect">
             <a:avLst/>
@@ -3386,7 +3397,7 @@
           <a:p>
             <a:pPr algn="l"/>
             <a:r>
-              <a:rPr sz="3000" b="1" i="0">
+              <a:rPr sz="3000" b="1" i="0" dirty="0">
                 <a:solidFill>
                   <a:srgbClr val="1A1A1A"/>
                 </a:solidFill>
@@ -3394,6 +3405,30 @@
               </a:rPr>
               <a:t>Contracts Settled in Three Currencies</a:t>
             </a:r>
+            <a:endParaRPr lang="en-US" sz="3000" b="1" i="0" dirty="0">
+              <a:solidFill>
+                <a:srgbClr val="1A1A1A"/>
+              </a:solidFill>
+              <a:latin typeface="Calibri"/>
+            </a:endParaRPr>
+          </a:p>
+          <a:p>
+            <a:pPr algn="l"/>
+            <a:r>
+              <a:rPr lang="en-US" sz="3000" b="1" dirty="0">
+                <a:solidFill>
+                  <a:srgbClr val="1A1A1A"/>
+                </a:solidFill>
+                <a:latin typeface="Calibri"/>
+              </a:rPr>
+              <a:t>(Not deployed)</a:t>
+            </a:r>
+            <a:endParaRPr sz="3000" b="1" i="0" dirty="0">
+              <a:solidFill>
+                <a:srgbClr val="1A1A1A"/>
+              </a:solidFill>
+              <a:latin typeface="Calibri"/>
+            </a:endParaRPr>
           </a:p>
         </p:txBody>
       </p:sp>
@@ -3433,7 +3468,7 @@
           </a:fontRef>
         </p:style>
         <p:txBody>
-          <a:bodyPr rtlCol="0" anchor="ctr" wrap="square" lIns="128016" rIns="128016" tIns="91440" bIns="91440"/>
+          <a:bodyPr wrap="square" lIns="128016" tIns="91440" rIns="128016" bIns="91440" rtlCol="0" anchor="ctr"/>
           <a:lstStyle/>
           <a:p>
             <a:pPr algn="ctr"/>
@@ -3491,6 +3526,7 @@
           <a:lstStyle/>
           <a:p>
             <a:pPr algn="ctr"/>
+            <a:endParaRPr/>
           </a:p>
         </p:txBody>
       </p:sp>
@@ -3581,7 +3617,7 @@
           </a:fontRef>
         </p:style>
         <p:txBody>
-          <a:bodyPr rtlCol="0" anchor="ctr" wrap="square" lIns="128016" rIns="128016" tIns="91440" bIns="91440"/>
+          <a:bodyPr wrap="square" lIns="128016" tIns="91440" rIns="128016" bIns="91440" rtlCol="0" anchor="ctr"/>
           <a:lstStyle/>
           <a:p>
             <a:pPr algn="ctr"/>
@@ -3639,6 +3675,7 @@
           <a:lstStyle/>
           <a:p>
             <a:pPr algn="ctr"/>
+            <a:endParaRPr/>
           </a:p>
         </p:txBody>
       </p:sp>
@@ -3729,7 +3766,7 @@
           </a:fontRef>
         </p:style>
         <p:txBody>
-          <a:bodyPr rtlCol="0" anchor="ctr" wrap="square" lIns="128016" rIns="128016" tIns="91440" bIns="91440"/>
+          <a:bodyPr wrap="square" lIns="128016" tIns="91440" rIns="128016" bIns="91440" rtlCol="0" anchor="ctr"/>
           <a:lstStyle/>
           <a:p>
             <a:pPr algn="ctr"/>
@@ -3787,6 +3824,7 @@
           <a:lstStyle/>
           <a:p>
             <a:pPr algn="ctr"/>
+            <a:endParaRPr/>
           </a:p>
         </p:txBody>
       </p:sp>
@@ -3850,7 +3888,7 @@
 </file>
 
 <file path=ppt/slides/slide11.xml><?xml version="1.0" encoding="utf-8"?>
-<p:sld xmlns:a="http://schemas.openxmlformats.org/drawingml/2006/main" xmlns:p="http://schemas.openxmlformats.org/presentationml/2006/main" xmlns:r="http://schemas.openxmlformats.org/officeDocument/2006/relationships">
+<p:sld xmlns:a="http://schemas.openxmlformats.org/drawingml/2006/main" xmlns:r="http://schemas.openxmlformats.org/officeDocument/2006/relationships" xmlns:p="http://schemas.openxmlformats.org/presentationml/2006/main">
   <p:cSld>
     <p:bg>
       <p:bgPr>
@@ -3866,7 +3904,14 @@
         <p:cNvGrpSpPr/>
         <p:nvPr/>
       </p:nvGrpSpPr>
-      <p:grpSpPr/>
+      <p:grpSpPr>
+        <a:xfrm>
+          <a:off x="0" y="0"/>
+          <a:ext cx="0" cy="0"/>
+          <a:chOff x="0" y="0"/>
+          <a:chExt cx="0" cy="0"/>
+        </a:xfrm>
+      </p:grpSpPr>
       <p:sp>
         <p:nvSpPr>
           <p:cNvPr id="2" name="TextBox 1"/>
@@ -3942,6 +3987,7 @@
           <a:lstStyle/>
           <a:p>
             <a:pPr algn="ctr"/>
+            <a:endParaRPr/>
           </a:p>
         </p:txBody>
       </p:sp>
@@ -3954,7 +4000,7 @@
         <p:spPr>
           <a:xfrm>
             <a:off x="411480" y="566928"/>
-            <a:ext cx="11338560" cy="1188720"/>
+            <a:ext cx="11338560" cy="1015663"/>
           </a:xfrm>
           <a:prstGeom prst="rect">
             <a:avLst/>
@@ -3969,7 +4015,7 @@
           <a:p>
             <a:pPr algn="l"/>
             <a:r>
-              <a:rPr sz="3000" b="1" i="0">
+              <a:rPr sz="3000" b="1" i="0" dirty="0">
                 <a:solidFill>
                   <a:srgbClr val="1A1A1A"/>
                 </a:solidFill>
@@ -3977,6 +4023,30 @@
               </a:rPr>
               <a:t>A Day in the Life</a:t>
             </a:r>
+            <a:endParaRPr lang="en-US" sz="3000" b="1" i="0" dirty="0">
+              <a:solidFill>
+                <a:srgbClr val="1A1A1A"/>
+              </a:solidFill>
+              <a:latin typeface="Calibri"/>
+            </a:endParaRPr>
+          </a:p>
+          <a:p>
+            <a:pPr algn="l"/>
+            <a:r>
+              <a:rPr lang="en-US" sz="3000" b="1" dirty="0">
+                <a:solidFill>
+                  <a:srgbClr val="1A1A1A"/>
+                </a:solidFill>
+                <a:latin typeface="Calibri"/>
+              </a:rPr>
+              <a:t>(Use case)</a:t>
+            </a:r>
+            <a:endParaRPr sz="3000" b="1" i="0" dirty="0">
+              <a:solidFill>
+                <a:srgbClr val="1A1A1A"/>
+              </a:solidFill>
+              <a:latin typeface="Calibri"/>
+            </a:endParaRPr>
           </a:p>
         </p:txBody>
       </p:sp>
@@ -4055,6 +4125,7 @@
           <a:lstStyle/>
           <a:p>
             <a:pPr algn="ctr"/>
+            <a:endParaRPr/>
           </a:p>
         </p:txBody>
       </p:sp>
@@ -4203,6 +4274,7 @@
           <a:lstStyle/>
           <a:p>
             <a:pPr algn="ctr"/>
+            <a:endParaRPr/>
           </a:p>
         </p:txBody>
       </p:sp>
@@ -4351,6 +4423,7 @@
           <a:lstStyle/>
           <a:p>
             <a:pPr algn="ctr"/>
+            <a:endParaRPr/>
           </a:p>
         </p:txBody>
       </p:sp>
@@ -4499,6 +4572,7 @@
           <a:lstStyle/>
           <a:p>
             <a:pPr algn="ctr"/>
+            <a:endParaRPr/>
           </a:p>
         </p:txBody>
       </p:sp>
@@ -4616,7 +4690,7 @@
 </file>
 
 <file path=ppt/slides/slide12.xml><?xml version="1.0" encoding="utf-8"?>
-<p:sld xmlns:a="http://schemas.openxmlformats.org/drawingml/2006/main" xmlns:p="http://schemas.openxmlformats.org/presentationml/2006/main" xmlns:r="http://schemas.openxmlformats.org/officeDocument/2006/relationships">
+<p:sld xmlns:a="http://schemas.openxmlformats.org/drawingml/2006/main" xmlns:r="http://schemas.openxmlformats.org/officeDocument/2006/relationships" xmlns:p="http://schemas.openxmlformats.org/presentationml/2006/main">
   <p:cSld>
     <p:bg>
       <p:bgPr>
@@ -4632,7 +4706,14 @@
         <p:cNvGrpSpPr/>
         <p:nvPr/>
       </p:nvGrpSpPr>
-      <p:grpSpPr/>
+      <p:grpSpPr>
+        <a:xfrm>
+          <a:off x="0" y="0"/>
+          <a:ext cx="0" cy="0"/>
+          <a:chOff x="0" y="0"/>
+          <a:chExt cx="0" cy="0"/>
+        </a:xfrm>
+      </p:grpSpPr>
       <p:sp>
         <p:nvSpPr>
           <p:cNvPr id="2" name="TextBox 1"/>
@@ -4708,6 +4789,7 @@
           <a:lstStyle/>
           <a:p>
             <a:pPr algn="ctr"/>
+            <a:endParaRPr/>
           </a:p>
         </p:txBody>
       </p:sp>
@@ -4788,6 +4870,7 @@
           <a:lstStyle/>
           <a:p>
             <a:pPr algn="ctr"/>
+            <a:endParaRPr/>
           </a:p>
         </p:txBody>
       </p:sp>
@@ -5010,7 +5093,7 @@
         <p:spPr>
           <a:xfrm>
             <a:off x="502920" y="4846320"/>
-            <a:ext cx="6858000" cy="475488"/>
+            <a:ext cx="6858000" cy="292388"/>
           </a:xfrm>
           <a:prstGeom prst="rect">
             <a:avLst/>
@@ -5025,13 +5108,31 @@
           <a:p>
             <a:pPr algn="l"/>
             <a:r>
-              <a:rPr sz="1300" b="0" i="0">
+              <a:rPr sz="1300" b="0" i="0" dirty="0">
                 <a:solidFill>
                   <a:srgbClr val="1A1A1A"/>
                 </a:solidFill>
                 <a:latin typeface="Calibri"/>
               </a:rPr>
-              <a:t>✓  8 credentials issued and verified; 5 NDCs with signing identities</a:t>
+              <a:t>✓  </a:t>
+            </a:r>
+            <a:r>
+              <a:rPr lang="en-US" sz="1300" dirty="0">
+                <a:solidFill>
+                  <a:srgbClr val="1A1A1A"/>
+                </a:solidFill>
+                <a:latin typeface="Calibri"/>
+              </a:rPr>
+              <a:t>C</a:t>
+            </a:r>
+            <a:r>
+              <a:rPr sz="1300" b="0" i="0" dirty="0">
+                <a:solidFill>
+                  <a:srgbClr val="1A1A1A"/>
+                </a:solidFill>
+                <a:latin typeface="Calibri"/>
+              </a:rPr>
+              <a:t>redentials issued and verified; 5 NDCs with signing identities</a:t>
             </a:r>
           </a:p>
         </p:txBody>
@@ -5078,6 +5179,7 @@
           <a:lstStyle/>
           <a:p>
             <a:pPr algn="ctr"/>
+            <a:endParaRPr/>
           </a:p>
         </p:txBody>
       </p:sp>
@@ -5230,7 +5332,7 @@
 </file>
 
 <file path=ppt/slides/slide13.xml><?xml version="1.0" encoding="utf-8"?>
-<p:sld xmlns:a="http://schemas.openxmlformats.org/drawingml/2006/main" xmlns:p="http://schemas.openxmlformats.org/presentationml/2006/main" xmlns:r="http://schemas.openxmlformats.org/officeDocument/2006/relationships">
+<p:sld xmlns:a="http://schemas.openxmlformats.org/drawingml/2006/main" xmlns:r="http://schemas.openxmlformats.org/officeDocument/2006/relationships" xmlns:p="http://schemas.openxmlformats.org/presentationml/2006/main">
   <p:cSld>
     <p:bg>
       <p:bgPr>
@@ -5246,7 +5348,14 @@
         <p:cNvGrpSpPr/>
         <p:nvPr/>
       </p:nvGrpSpPr>
-      <p:grpSpPr/>
+      <p:grpSpPr>
+        <a:xfrm>
+          <a:off x="0" y="0"/>
+          <a:ext cx="0" cy="0"/>
+          <a:chOff x="0" y="0"/>
+          <a:chExt cx="0" cy="0"/>
+        </a:xfrm>
+      </p:grpSpPr>
       <p:sp>
         <p:nvSpPr>
           <p:cNvPr id="2" name="TextBox 1"/>
@@ -5322,6 +5431,7 @@
           <a:lstStyle/>
           <a:p>
             <a:pPr algn="ctr"/>
+            <a:endParaRPr/>
           </a:p>
         </p:txBody>
       </p:sp>
@@ -5400,6 +5510,7 @@
           <a:lstStyle/>
           <a:p>
             <a:pPr algn="ctr"/>
+            <a:endParaRPr/>
           </a:p>
         </p:txBody>
       </p:sp>
@@ -5521,6 +5632,7 @@
           <a:lstStyle/>
           <a:p>
             <a:pPr algn="ctr"/>
+            <a:endParaRPr/>
           </a:p>
         </p:txBody>
       </p:sp>
@@ -5604,13 +5716,65 @@
       </p:sp>
       <p:sp>
         <p:nvSpPr>
-          <p:cNvPr id="11" name="Oval 10"/>
+          <p:cNvPr id="13" name="TextBox 12"/>
+          <p:cNvSpPr txBox="1"/>
+          <p:nvPr/>
+        </p:nvSpPr>
+        <p:spPr>
+          <a:xfrm>
+            <a:off x="960120" y="5350741"/>
+            <a:ext cx="10789920" cy="353943"/>
+          </a:xfrm>
+          <a:prstGeom prst="rect">
+            <a:avLst/>
+          </a:prstGeom>
+          <a:noFill/>
+        </p:spPr>
+        <p:txBody>
+          <a:bodyPr wrap="square">
+            <a:spAutoFit/>
+          </a:bodyPr>
+          <a:lstStyle/>
+          <a:p>
+            <a:r>
+              <a:rPr lang="en-US" sz="1700" b="1" dirty="0">
+                <a:solidFill>
+                  <a:srgbClr val="2D6A4F"/>
+                </a:solidFill>
+                <a:latin typeface="Calibri"/>
+              </a:rPr>
+              <a:t>Future--</a:t>
+            </a:r>
+            <a:r>
+              <a:rPr sz="1700" b="1" dirty="0">
+                <a:solidFill>
+                  <a:srgbClr val="2D6A4F"/>
+                </a:solidFill>
+                <a:latin typeface="Calibri"/>
+              </a:rPr>
+              <a:t>A fair contract system  </a:t>
+            </a:r>
+            <a:r>
+              <a:rPr sz="1600" dirty="0">
+                <a:solidFill>
+                  <a:srgbClr val="1A1A1A"/>
+                </a:solidFill>
+                <a:latin typeface="Calibri"/>
+              </a:rPr>
+              <a:t>that recognizes dollars, time-dollars, and gift — not just cash.</a:t>
+            </a:r>
+          </a:p>
+        </p:txBody>
+      </p:sp>
+      <p:sp>
+        <p:nvSpPr>
+          <p:cNvPr id="14" name="Oval 13"/>
           <p:cNvSpPr/>
           <p:nvPr/>
         </p:nvSpPr>
         <p:spPr>
           <a:xfrm>
-            <a:off x="411480" y="3694176"/>
+            <a:off x="411480" y="3584448"/>
             <a:ext cx="365760" cy="365760"/>
           </a:xfrm>
           <a:prstGeom prst="ellipse">
@@ -5642,19 +5806,20 @@
           <a:lstStyle/>
           <a:p>
             <a:pPr algn="ctr"/>
-          </a:p>
-        </p:txBody>
-      </p:sp>
-      <p:sp>
-        <p:nvSpPr>
-          <p:cNvPr id="12" name="TextBox 11"/>
-          <p:cNvSpPr txBox="1"/>
-          <p:nvPr/>
-        </p:nvSpPr>
-        <p:spPr>
-          <a:xfrm>
-            <a:off x="429768" y="3721608"/>
-            <a:ext cx="347472" cy="320040"/>
+            <a:endParaRPr/>
+          </a:p>
+        </p:txBody>
+      </p:sp>
+      <p:sp>
+        <p:nvSpPr>
+          <p:cNvPr id="15" name="TextBox 14"/>
+          <p:cNvSpPr txBox="1"/>
+          <p:nvPr/>
+        </p:nvSpPr>
+        <p:spPr>
+          <a:xfrm>
+            <a:off x="429768" y="3611880"/>
+            <a:ext cx="347472" cy="276999"/>
           </a:xfrm>
           <a:prstGeom prst="rect">
             <a:avLst/>
@@ -5669,7 +5834,7 @@
           <a:p>
             <a:pPr algn="ctr"/>
             <a:r>
-              <a:rPr sz="1200" b="1" i="0">
+              <a:rPr lang="en-US" sz="1200" b="1" i="0" dirty="0">
                 <a:solidFill>
                   <a:srgbClr val="FFFFFF"/>
                 </a:solidFill>
@@ -5677,18 +5842,24 @@
               </a:rPr>
               <a:t>3</a:t>
             </a:r>
-          </a:p>
-        </p:txBody>
-      </p:sp>
-      <p:sp>
-        <p:nvSpPr>
-          <p:cNvPr id="13" name="TextBox 12"/>
-          <p:cNvSpPr txBox="1"/>
-          <p:nvPr/>
-        </p:nvSpPr>
-        <p:spPr>
-          <a:xfrm>
-            <a:off x="960120" y="3602736"/>
+            <a:endParaRPr sz="1200" b="1" i="0" dirty="0">
+              <a:solidFill>
+                <a:srgbClr val="FFFFFF"/>
+              </a:solidFill>
+              <a:latin typeface="Calibri"/>
+            </a:endParaRPr>
+          </a:p>
+        </p:txBody>
+      </p:sp>
+      <p:sp>
+        <p:nvSpPr>
+          <p:cNvPr id="16" name="TextBox 15"/>
+          <p:cNvSpPr txBox="1"/>
+          <p:nvPr/>
+        </p:nvSpPr>
+        <p:spPr>
+          <a:xfrm>
+            <a:off x="960120" y="3493008"/>
             <a:ext cx="10789920" cy="822960"/>
           </a:xfrm>
           <a:prstGeom prst="rect">
@@ -5709,7 +5880,7 @@
                 </a:solidFill>
                 <a:latin typeface="Calibri"/>
               </a:rPr>
-              <a:t>A fair contract system  </a:t>
+              <a:t>A teaching chain  </a:t>
             </a:r>
             <a:r>
               <a:rPr sz="1600">
@@ -5718,20 +5889,20 @@
                 </a:solidFill>
                 <a:latin typeface="Calibri"/>
               </a:rPr>
-              <a:t>that recognizes dollars, time-dollars, and gift — not just cash.</a:t>
-            </a:r>
-          </a:p>
-        </p:txBody>
-      </p:sp>
-      <p:sp>
-        <p:nvSpPr>
-          <p:cNvPr id="14" name="Oval 13"/>
+              <a:t>that grows with every credential issued. Knowledge doesn't leave when people do.</a:t>
+            </a:r>
+          </a:p>
+        </p:txBody>
+      </p:sp>
+      <p:sp>
+        <p:nvSpPr>
+          <p:cNvPr id="17" name="Oval 16"/>
           <p:cNvSpPr/>
           <p:nvPr/>
         </p:nvSpPr>
         <p:spPr>
           <a:xfrm>
-            <a:off x="411480" y="4626864"/>
+            <a:off x="411480" y="4517136"/>
             <a:ext cx="365760" cy="365760"/>
           </a:xfrm>
           <a:prstGeom prst="ellipse">
@@ -5763,19 +5934,20 @@
           <a:lstStyle/>
           <a:p>
             <a:pPr algn="ctr"/>
-          </a:p>
-        </p:txBody>
-      </p:sp>
-      <p:sp>
-        <p:nvSpPr>
-          <p:cNvPr id="15" name="TextBox 14"/>
-          <p:cNvSpPr txBox="1"/>
-          <p:nvPr/>
-        </p:nvSpPr>
-        <p:spPr>
-          <a:xfrm>
-            <a:off x="429768" y="4654296"/>
-            <a:ext cx="347472" cy="320040"/>
+            <a:endParaRPr/>
+          </a:p>
+        </p:txBody>
+      </p:sp>
+      <p:sp>
+        <p:nvSpPr>
+          <p:cNvPr id="18" name="TextBox 17"/>
+          <p:cNvSpPr txBox="1"/>
+          <p:nvPr/>
+        </p:nvSpPr>
+        <p:spPr>
+          <a:xfrm>
+            <a:off x="429768" y="4544568"/>
+            <a:ext cx="347472" cy="276999"/>
           </a:xfrm>
           <a:prstGeom prst="rect">
             <a:avLst/>
@@ -5790,7 +5962,7 @@
           <a:p>
             <a:pPr algn="ctr"/>
             <a:r>
-              <a:rPr sz="1200" b="1" i="0">
+              <a:rPr lang="en-US" sz="1200" b="1" i="0" dirty="0">
                 <a:solidFill>
                   <a:srgbClr val="FFFFFF"/>
                 </a:solidFill>
@@ -5798,61 +5970,79 @@
               </a:rPr>
               <a:t>4</a:t>
             </a:r>
-          </a:p>
-        </p:txBody>
-      </p:sp>
-      <p:sp>
-        <p:nvSpPr>
-          <p:cNvPr id="16" name="TextBox 15"/>
-          <p:cNvSpPr txBox="1"/>
-          <p:nvPr/>
-        </p:nvSpPr>
-        <p:spPr>
-          <a:xfrm>
-            <a:off x="960120" y="4535424"/>
-            <a:ext cx="10789920" cy="822960"/>
-          </a:xfrm>
-          <a:prstGeom prst="rect">
-            <a:avLst/>
-          </a:prstGeom>
-          <a:noFill/>
-        </p:spPr>
-        <p:txBody>
-          <a:bodyPr wrap="square">
-            <a:spAutoFit/>
-          </a:bodyPr>
-          <a:lstStyle/>
-          <a:p>
-            <a:r>
-              <a:rPr sz="1700" b="1">
+            <a:endParaRPr sz="1200" b="1" i="0" dirty="0">
+              <a:solidFill>
+                <a:srgbClr val="FFFFFF"/>
+              </a:solidFill>
+              <a:latin typeface="Calibri"/>
+            </a:endParaRPr>
+          </a:p>
+        </p:txBody>
+      </p:sp>
+      <p:sp>
+        <p:nvSpPr>
+          <p:cNvPr id="19" name="TextBox 18"/>
+          <p:cNvSpPr txBox="1"/>
+          <p:nvPr/>
+        </p:nvSpPr>
+        <p:spPr>
+          <a:xfrm>
+            <a:off x="960120" y="4425696"/>
+            <a:ext cx="10789920" cy="600164"/>
+          </a:xfrm>
+          <a:prstGeom prst="rect">
+            <a:avLst/>
+          </a:prstGeom>
+          <a:noFill/>
+        </p:spPr>
+        <p:txBody>
+          <a:bodyPr wrap="square">
+            <a:spAutoFit/>
+          </a:bodyPr>
+          <a:lstStyle/>
+          <a:p>
+            <a:r>
+              <a:rPr sz="1700" b="1" dirty="0">
                 <a:solidFill>
                   <a:srgbClr val="2D6A4F"/>
                 </a:solidFill>
                 <a:latin typeface="Calibri"/>
               </a:rPr>
-              <a:t>A teaching chain  </a:t>
-            </a:r>
-            <a:r>
-              <a:rPr sz="1600">
+              <a:t>Connection to the RCN network  </a:t>
+            </a:r>
+            <a:r>
+              <a:rPr sz="1600" dirty="0">
                 <a:solidFill>
                   <a:srgbClr val="1A1A1A"/>
                 </a:solidFill>
                 <a:latin typeface="Calibri"/>
               </a:rPr>
-              <a:t>that grows with every credential issued. Knowledge doesn't leave when people do.</a:t>
-            </a:r>
-          </a:p>
-        </p:txBody>
-      </p:sp>
-      <p:sp>
-        <p:nvSpPr>
-          <p:cNvPr id="17" name="Oval 16"/>
+              <a:t>of NDCs — credential holders recognized across the network, skills shared between communities.</a:t>
+            </a:r>
+            <a:endParaRPr lang="en-US" sz="1600" dirty="0">
+              <a:solidFill>
+                <a:srgbClr val="1A1A1A"/>
+              </a:solidFill>
+              <a:latin typeface="Calibri"/>
+            </a:endParaRPr>
+          </a:p>
+        </p:txBody>
+      </p:sp>
+      <p:sp>
+        <p:nvSpPr>
+          <p:cNvPr id="25" name="Oval 24">
+            <a:extLst>
+              <a:ext uri="{FF2B5EF4-FFF2-40B4-BE49-F238E27FC236}">
+                <a16:creationId xmlns:a16="http://schemas.microsoft.com/office/drawing/2014/main" id="{D664B7BF-CF37-CA77-C4E8-29A1243AFD52}"/>
+              </a:ext>
+            </a:extLst>
+          </p:cNvPr>
           <p:cNvSpPr/>
           <p:nvPr/>
         </p:nvSpPr>
         <p:spPr>
           <a:xfrm>
-            <a:off x="411480" y="5559552"/>
+            <a:off x="411480" y="5396461"/>
             <a:ext cx="365760" cy="365760"/>
           </a:xfrm>
           <a:prstGeom prst="ellipse">
@@ -5884,19 +6074,26 @@
           <a:lstStyle/>
           <a:p>
             <a:pPr algn="ctr"/>
-          </a:p>
-        </p:txBody>
-      </p:sp>
-      <p:sp>
-        <p:nvSpPr>
-          <p:cNvPr id="18" name="TextBox 17"/>
-          <p:cNvSpPr txBox="1"/>
-          <p:nvPr/>
-        </p:nvSpPr>
-        <p:spPr>
-          <a:xfrm>
-            <a:off x="429768" y="5586984"/>
-            <a:ext cx="347472" cy="320040"/>
+            <a:endParaRPr/>
+          </a:p>
+        </p:txBody>
+      </p:sp>
+      <p:sp>
+        <p:nvSpPr>
+          <p:cNvPr id="26" name="TextBox 25">
+            <a:extLst>
+              <a:ext uri="{FF2B5EF4-FFF2-40B4-BE49-F238E27FC236}">
+                <a16:creationId xmlns:a16="http://schemas.microsoft.com/office/drawing/2014/main" id="{F84C8DD2-3FD3-3D32-77BC-5428CAD1589C}"/>
+              </a:ext>
+            </a:extLst>
+          </p:cNvPr>
+          <p:cNvSpPr txBox="1"/>
+          <p:nvPr/>
+        </p:nvSpPr>
+        <p:spPr>
+          <a:xfrm>
+            <a:off x="438785" y="5449824"/>
+            <a:ext cx="347472" cy="276999"/>
           </a:xfrm>
           <a:prstGeom prst="rect">
             <a:avLst/>
@@ -5911,7 +6108,7 @@
           <a:p>
             <a:pPr algn="ctr"/>
             <a:r>
-              <a:rPr sz="1200" b="1" i="0">
+              <a:rPr lang="en-US" sz="1200" b="1" dirty="0">
                 <a:solidFill>
                   <a:srgbClr val="FFFFFF"/>
                 </a:solidFill>
@@ -5919,49 +6116,12 @@
               </a:rPr>
               <a:t>5</a:t>
             </a:r>
-          </a:p>
-        </p:txBody>
-      </p:sp>
-      <p:sp>
-        <p:nvSpPr>
-          <p:cNvPr id="19" name="TextBox 18"/>
-          <p:cNvSpPr txBox="1"/>
-          <p:nvPr/>
-        </p:nvSpPr>
-        <p:spPr>
-          <a:xfrm>
-            <a:off x="960120" y="5468112"/>
-            <a:ext cx="10789920" cy="822960"/>
-          </a:xfrm>
-          <a:prstGeom prst="rect">
-            <a:avLst/>
-          </a:prstGeom>
-          <a:noFill/>
-        </p:spPr>
-        <p:txBody>
-          <a:bodyPr wrap="square">
-            <a:spAutoFit/>
-          </a:bodyPr>
-          <a:lstStyle/>
-          <a:p>
-            <a:r>
-              <a:rPr sz="1700" b="1">
-                <a:solidFill>
-                  <a:srgbClr val="2D6A4F"/>
-                </a:solidFill>
-                <a:latin typeface="Calibri"/>
-              </a:rPr>
-              <a:t>Connection to the RCN network  </a:t>
-            </a:r>
-            <a:r>
-              <a:rPr sz="1600">
-                <a:solidFill>
-                  <a:srgbClr val="1A1A1A"/>
-                </a:solidFill>
-                <a:latin typeface="Calibri"/>
-              </a:rPr>
-              <a:t>of NDCs — credential holders recognized across the network, skills shared between communities.</a:t>
-            </a:r>
+            <a:endParaRPr sz="1200" b="1" i="0" dirty="0">
+              <a:solidFill>
+                <a:srgbClr val="FFFFFF"/>
+              </a:solidFill>
+              <a:latin typeface="Calibri"/>
+            </a:endParaRPr>
           </a:p>
         </p:txBody>
       </p:sp>
@@ -5974,7 +6134,7 @@
 </file>
 
 <file path=ppt/slides/slide14.xml><?xml version="1.0" encoding="utf-8"?>
-<p:sld xmlns:a="http://schemas.openxmlformats.org/drawingml/2006/main" xmlns:p="http://schemas.openxmlformats.org/presentationml/2006/main" xmlns:r="http://schemas.openxmlformats.org/officeDocument/2006/relationships">
+<p:sld xmlns:a="http://schemas.openxmlformats.org/drawingml/2006/main" xmlns:r="http://schemas.openxmlformats.org/officeDocument/2006/relationships" xmlns:p="http://schemas.openxmlformats.org/presentationml/2006/main">
   <p:cSld>
     <p:bg>
       <p:bgPr>
@@ -5990,7 +6150,14 @@
         <p:cNvGrpSpPr/>
         <p:nvPr/>
       </p:nvGrpSpPr>
-      <p:grpSpPr/>
+      <p:grpSpPr>
+        <a:xfrm>
+          <a:off x="0" y="0"/>
+          <a:ext cx="0" cy="0"/>
+          <a:chOff x="0" y="0"/>
+          <a:chExt cx="0" cy="0"/>
+        </a:xfrm>
+      </p:grpSpPr>
       <p:sp>
         <p:nvSpPr>
           <p:cNvPr id="2" name="TextBox 1"/>
@@ -6066,6 +6233,7 @@
           <a:lstStyle/>
           <a:p>
             <a:pPr algn="ctr"/>
+            <a:endParaRPr/>
           </a:p>
         </p:txBody>
       </p:sp>
@@ -6146,6 +6314,7 @@
           <a:lstStyle/>
           <a:p>
             <a:pPr algn="ctr"/>
+            <a:endParaRPr/>
           </a:p>
         </p:txBody>
       </p:sp>
@@ -6261,6 +6430,7 @@
           <a:lstStyle/>
           <a:p>
             <a:pPr algn="ctr"/>
+            <a:endParaRPr/>
           </a:p>
         </p:txBody>
       </p:sp>
@@ -6376,6 +6546,7 @@
           <a:lstStyle/>
           <a:p>
             <a:pPr algn="ctr"/>
+            <a:endParaRPr/>
           </a:p>
         </p:txBody>
       </p:sp>
@@ -6458,7 +6629,7 @@
 </file>
 
 <file path=ppt/slides/slide15.xml><?xml version="1.0" encoding="utf-8"?>
-<p:sld xmlns:a="http://schemas.openxmlformats.org/drawingml/2006/main" xmlns:p="http://schemas.openxmlformats.org/presentationml/2006/main" xmlns:r="http://schemas.openxmlformats.org/officeDocument/2006/relationships">
+<p:sld xmlns:a="http://schemas.openxmlformats.org/drawingml/2006/main" xmlns:r="http://schemas.openxmlformats.org/officeDocument/2006/relationships" xmlns:p="http://schemas.openxmlformats.org/presentationml/2006/main">
   <p:cSld>
     <p:bg>
       <p:bgPr>
@@ -6474,7 +6645,14 @@
         <p:cNvGrpSpPr/>
         <p:nvPr/>
       </p:nvGrpSpPr>
-      <p:grpSpPr/>
+      <p:grpSpPr>
+        <a:xfrm>
+          <a:off x="0" y="0"/>
+          <a:ext cx="0" cy="0"/>
+          <a:chOff x="0" y="0"/>
+          <a:chExt cx="0" cy="0"/>
+        </a:xfrm>
+      </p:grpSpPr>
       <p:sp>
         <p:nvSpPr>
           <p:cNvPr id="2" name="TextBox 1"/>
@@ -6550,6 +6728,7 @@
           <a:lstStyle/>
           <a:p>
             <a:pPr algn="ctr"/>
+            <a:endParaRPr/>
           </a:p>
         </p:txBody>
       </p:sp>
@@ -6703,7 +6882,7 @@
 </file>
 
 <file path=ppt/slides/slide2.xml><?xml version="1.0" encoding="utf-8"?>
-<p:sld xmlns:a="http://schemas.openxmlformats.org/drawingml/2006/main" xmlns:p="http://schemas.openxmlformats.org/presentationml/2006/main" xmlns:r="http://schemas.openxmlformats.org/officeDocument/2006/relationships">
+<p:sld xmlns:a="http://schemas.openxmlformats.org/drawingml/2006/main" xmlns:r="http://schemas.openxmlformats.org/officeDocument/2006/relationships" xmlns:p="http://schemas.openxmlformats.org/presentationml/2006/main">
   <p:cSld>
     <p:bg>
       <p:bgPr>
@@ -6719,7 +6898,14 @@
         <p:cNvGrpSpPr/>
         <p:nvPr/>
       </p:nvGrpSpPr>
-      <p:grpSpPr/>
+      <p:grpSpPr>
+        <a:xfrm>
+          <a:off x="0" y="0"/>
+          <a:ext cx="0" cy="0"/>
+          <a:chOff x="0" y="0"/>
+          <a:chExt cx="0" cy="0"/>
+        </a:xfrm>
+      </p:grpSpPr>
       <p:sp>
         <p:nvSpPr>
           <p:cNvPr id="2" name="TextBox 1"/>
@@ -6795,6 +6981,7 @@
           <a:lstStyle/>
           <a:p>
             <a:pPr algn="ctr"/>
+            <a:endParaRPr/>
           </a:p>
         </p:txBody>
       </p:sp>
@@ -6964,7 +7151,7 @@
 </file>
 
 <file path=ppt/slides/slide3.xml><?xml version="1.0" encoding="utf-8"?>
-<p:sld xmlns:a="http://schemas.openxmlformats.org/drawingml/2006/main" xmlns:p="http://schemas.openxmlformats.org/presentationml/2006/main" xmlns:r="http://schemas.openxmlformats.org/officeDocument/2006/relationships">
+<p:sld xmlns:a="http://schemas.openxmlformats.org/drawingml/2006/main" xmlns:r="http://schemas.openxmlformats.org/officeDocument/2006/relationships" xmlns:p="http://schemas.openxmlformats.org/presentationml/2006/main">
   <p:cSld>
     <p:bg>
       <p:bgPr>
@@ -6980,7 +7167,14 @@
         <p:cNvGrpSpPr/>
         <p:nvPr/>
       </p:nvGrpSpPr>
-      <p:grpSpPr/>
+      <p:grpSpPr>
+        <a:xfrm>
+          <a:off x="0" y="0"/>
+          <a:ext cx="0" cy="0"/>
+          <a:chOff x="0" y="0"/>
+          <a:chExt cx="0" cy="0"/>
+        </a:xfrm>
+      </p:grpSpPr>
       <p:sp>
         <p:nvSpPr>
           <p:cNvPr id="2" name="TextBox 1"/>
@@ -7056,6 +7250,7 @@
           <a:lstStyle/>
           <a:p>
             <a:pPr algn="ctr"/>
+            <a:endParaRPr/>
           </a:p>
         </p:txBody>
       </p:sp>
@@ -7202,7 +7397,7 @@
           </a:fontRef>
         </p:style>
         <p:txBody>
-          <a:bodyPr rtlCol="0" anchor="ctr" wrap="square" lIns="128016" rIns="128016" tIns="91440" bIns="91440"/>
+          <a:bodyPr wrap="square" lIns="128016" tIns="91440" rIns="128016" bIns="91440" rtlCol="0" anchor="ctr"/>
           <a:lstStyle/>
           <a:p>
             <a:pPr algn="ctr"/>
@@ -7256,7 +7451,7 @@
           </a:fontRef>
         </p:style>
         <p:txBody>
-          <a:bodyPr rtlCol="0" anchor="ctr" wrap="square" lIns="128016" rIns="128016" tIns="91440" bIns="91440"/>
+          <a:bodyPr wrap="square" lIns="128016" tIns="91440" rIns="128016" bIns="91440" rtlCol="0" anchor="ctr"/>
           <a:lstStyle/>
           <a:p>
             <a:pPr algn="ctr"/>
@@ -7310,7 +7505,7 @@
           </a:fontRef>
         </p:style>
         <p:txBody>
-          <a:bodyPr rtlCol="0" anchor="ctr" wrap="square" lIns="128016" rIns="128016" tIns="91440" bIns="91440"/>
+          <a:bodyPr wrap="square" lIns="128016" tIns="91440" rIns="128016" bIns="91440" rtlCol="0" anchor="ctr"/>
           <a:lstStyle/>
           <a:p>
             <a:pPr algn="ctr"/>
@@ -7335,7 +7530,7 @@
 </file>
 
 <file path=ppt/slides/slide4.xml><?xml version="1.0" encoding="utf-8"?>
-<p:sld xmlns:a="http://schemas.openxmlformats.org/drawingml/2006/main" xmlns:p="http://schemas.openxmlformats.org/presentationml/2006/main" xmlns:r="http://schemas.openxmlformats.org/officeDocument/2006/relationships">
+<p:sld xmlns:a="http://schemas.openxmlformats.org/drawingml/2006/main" xmlns:r="http://schemas.openxmlformats.org/officeDocument/2006/relationships" xmlns:p="http://schemas.openxmlformats.org/presentationml/2006/main">
   <p:cSld>
     <p:bg>
       <p:bgPr>
@@ -7351,7 +7546,14 @@
         <p:cNvGrpSpPr/>
         <p:nvPr/>
       </p:nvGrpSpPr>
-      <p:grpSpPr/>
+      <p:grpSpPr>
+        <a:xfrm>
+          <a:off x="0" y="0"/>
+          <a:ext cx="0" cy="0"/>
+          <a:chOff x="0" y="0"/>
+          <a:chExt cx="0" cy="0"/>
+        </a:xfrm>
+      </p:grpSpPr>
       <p:sp>
         <p:nvSpPr>
           <p:cNvPr id="2" name="TextBox 1"/>
@@ -7427,6 +7629,7 @@
           <a:lstStyle/>
           <a:p>
             <a:pPr algn="ctr"/>
+            <a:endParaRPr/>
           </a:p>
         </p:txBody>
       </p:sp>
@@ -7538,12 +7741,12 @@
           </a:fontRef>
         </p:style>
         <p:txBody>
-          <a:bodyPr rtlCol="0" anchor="ctr" wrap="square" lIns="182880" rIns="182880" tIns="164592" bIns="137160"/>
+          <a:bodyPr wrap="square" lIns="182880" tIns="164592" rIns="182880" bIns="137160" rtlCol="0" anchor="ctr"/>
           <a:lstStyle/>
           <a:p>
             <a:pPr algn="ctr"/>
             <a:r>
-              <a:rPr sz="1600" b="1">
+              <a:rPr sz="1600" b="1" dirty="0">
                 <a:solidFill>
                   <a:srgbClr val="2D6A4F"/>
                 </a:solidFill>
@@ -7555,7 +7758,7 @@
           <a:p>
             <a:pPr algn="ctr"/>
             <a:r>
-              <a:rPr sz="1400" b="0">
+              <a:rPr sz="1400" b="0" dirty="0">
                 <a:solidFill>
                   <a:srgbClr val="1A1A1A"/>
                 </a:solidFill>
@@ -7566,39 +7769,75 @@
           </a:p>
           <a:p>
             <a:pPr algn="ctr"/>
-            <a:r>
-              <a:rPr sz="1400" b="0">
+            <a:endParaRPr sz="1400" b="0" dirty="0">
+              <a:solidFill>
+                <a:srgbClr val="1A1A1A"/>
+              </a:solidFill>
+              <a:latin typeface="Calibri"/>
+            </a:endParaRPr>
+          </a:p>
+          <a:p>
+            <a:pPr algn="ctr"/>
+            <a:r>
+              <a:rPr sz="1400" b="0" dirty="0">
                 <a:solidFill>
                   <a:srgbClr val="1A1A1A"/>
                 </a:solidFill>
                 <a:latin typeface="Calibri"/>
               </a:rPr>
-              <a:t/>
-            </a:r>
+              <a:t>Your mentor demonstrates.</a:t>
+            </a:r>
+            <a:endParaRPr lang="en-US" sz="1400" b="0" dirty="0">
+              <a:solidFill>
+                <a:srgbClr val="1A1A1A"/>
+              </a:solidFill>
+              <a:latin typeface="Calibri"/>
+            </a:endParaRPr>
           </a:p>
           <a:p>
             <a:pPr algn="ctr"/>
             <a:r>
-              <a:rPr sz="1400" b="0">
+              <a:rPr lang="en-US" sz="1400" dirty="0">
                 <a:solidFill>
                   <a:srgbClr val="1A1A1A"/>
                 </a:solidFill>
                 <a:latin typeface="Calibri"/>
               </a:rPr>
-              <a:t>Your mentor demonstrates.</a:t>
-            </a:r>
+              <a:t>You may request to be shown repeatedly.</a:t>
+            </a:r>
+            <a:endParaRPr sz="1400" b="0" dirty="0">
+              <a:solidFill>
+                <a:srgbClr val="1A1A1A"/>
+              </a:solidFill>
+              <a:latin typeface="Calibri"/>
+            </a:endParaRPr>
           </a:p>
           <a:p>
             <a:pPr algn="ctr"/>
             <a:r>
-              <a:rPr sz="1400" b="0">
+              <a:rPr sz="1400" b="0" dirty="0">
                 <a:solidFill>
                   <a:srgbClr val="1A1A1A"/>
                 </a:solidFill>
                 <a:latin typeface="Calibri"/>
               </a:rPr>
-              <a:t>You observe and attest.</a:t>
-            </a:r>
+              <a:t>You observe and attest</a:t>
+            </a:r>
+            <a:r>
+              <a:rPr lang="en-US" sz="1400" b="0" dirty="0">
+                <a:solidFill>
+                  <a:srgbClr val="1A1A1A"/>
+                </a:solidFill>
+                <a:latin typeface="Calibri"/>
+              </a:rPr>
+              <a:t> that you understand how to perform the skill.</a:t>
+            </a:r>
+            <a:endParaRPr sz="1400" b="0" dirty="0">
+              <a:solidFill>
+                <a:srgbClr val="1A1A1A"/>
+              </a:solidFill>
+              <a:latin typeface="Calibri"/>
+            </a:endParaRPr>
           </a:p>
         </p:txBody>
       </p:sp>
@@ -7710,12 +7949,12 @@
           </a:fontRef>
         </p:style>
         <p:txBody>
-          <a:bodyPr rtlCol="0" anchor="ctr" wrap="square" lIns="182880" rIns="182880" tIns="164592" bIns="137160"/>
+          <a:bodyPr wrap="square" lIns="182880" tIns="164592" rIns="182880" bIns="137160" rtlCol="0" anchor="ctr"/>
           <a:lstStyle/>
           <a:p>
             <a:pPr algn="ctr"/>
             <a:r>
-              <a:rPr sz="1600" b="1">
+              <a:rPr sz="1600" b="1" dirty="0">
                 <a:solidFill>
                   <a:srgbClr val="1A56A4"/>
                 </a:solidFill>
@@ -7727,7 +7966,7 @@
           <a:p>
             <a:pPr algn="ctr"/>
             <a:r>
-              <a:rPr sz="1400" b="0">
+              <a:rPr sz="1400" b="0" dirty="0">
                 <a:solidFill>
                   <a:srgbClr val="1A1A1A"/>
                 </a:solidFill>
@@ -7738,38 +7977,53 @@
           </a:p>
           <a:p>
             <a:pPr algn="ctr"/>
-            <a:r>
-              <a:rPr sz="1400" b="0">
+            <a:endParaRPr sz="1400" b="0" dirty="0">
+              <a:solidFill>
+                <a:srgbClr val="1A1A1A"/>
+              </a:solidFill>
+              <a:latin typeface="Calibri"/>
+            </a:endParaRPr>
+          </a:p>
+          <a:p>
+            <a:pPr algn="ctr"/>
+            <a:r>
+              <a:rPr sz="1400" b="0" dirty="0">
                 <a:solidFill>
                   <a:srgbClr val="1A1A1A"/>
                 </a:solidFill>
                 <a:latin typeface="Calibri"/>
               </a:rPr>
-              <a:t/>
+              <a:t>Both of you attest.</a:t>
             </a:r>
           </a:p>
           <a:p>
             <a:pPr algn="ctr"/>
             <a:r>
-              <a:rPr sz="1400" b="0">
+              <a:rPr sz="1400" b="0" dirty="0">
                 <a:solidFill>
                   <a:srgbClr val="1A1A1A"/>
                 </a:solidFill>
                 <a:latin typeface="Calibri"/>
               </a:rPr>
-              <a:t>Both of you attest.</a:t>
-            </a:r>
-          </a:p>
-          <a:p>
-            <a:pPr algn="ctr"/>
-            <a:r>
-              <a:rPr sz="1400" b="0">
+              <a:t>You may try again </a:t>
+            </a:r>
+            <a:r>
+              <a:rPr lang="en-US" sz="1400" dirty="0">
                 <a:solidFill>
                   <a:srgbClr val="1A1A1A"/>
                 </a:solidFill>
                 <a:latin typeface="Calibri"/>
               </a:rPr>
-              <a:t>You may try again if needed.</a:t>
+              <a:t>as </a:t>
+            </a:r>
+            <a:r>
+              <a:rPr sz="1400" b="0" dirty="0">
+                <a:solidFill>
+                  <a:srgbClr val="1A1A1A"/>
+                </a:solidFill>
+                <a:latin typeface="Calibri"/>
+              </a:rPr>
+              <a:t>needed.</a:t>
             </a:r>
           </a:p>
         </p:txBody>
@@ -7882,12 +8136,12 @@
           </a:fontRef>
         </p:style>
         <p:txBody>
-          <a:bodyPr rtlCol="0" anchor="ctr" wrap="square" lIns="182880" rIns="182880" tIns="164592" bIns="137160"/>
+          <a:bodyPr wrap="square" lIns="182880" tIns="164592" rIns="182880" bIns="137160" rtlCol="0" anchor="ctr"/>
           <a:lstStyle/>
           <a:p>
             <a:pPr algn="ctr"/>
             <a:r>
-              <a:rPr sz="1600" b="1">
+              <a:rPr sz="1600" b="1" dirty="0">
                 <a:solidFill>
                   <a:srgbClr val="92400E"/>
                 </a:solidFill>
@@ -7899,7 +8153,7 @@
           <a:p>
             <a:pPr algn="ctr"/>
             <a:r>
-              <a:rPr sz="1400" b="0">
+              <a:rPr sz="1400" b="0" dirty="0">
                 <a:solidFill>
                   <a:srgbClr val="1A1A1A"/>
                 </a:solidFill>
@@ -7910,39 +8164,78 @@
           </a:p>
           <a:p>
             <a:pPr algn="ctr"/>
-            <a:r>
-              <a:rPr sz="1400" b="0">
+            <a:endParaRPr sz="1400" b="0" dirty="0">
+              <a:solidFill>
+                <a:srgbClr val="1A1A1A"/>
+              </a:solidFill>
+              <a:latin typeface="Calibri"/>
+            </a:endParaRPr>
+          </a:p>
+          <a:p>
+            <a:pPr algn="ctr"/>
+            <a:r>
+              <a:rPr sz="1400" b="0" dirty="0">
                 <a:solidFill>
                   <a:srgbClr val="1A1A1A"/>
                 </a:solidFill>
                 <a:latin typeface="Calibri"/>
               </a:rPr>
-              <a:t/>
+              <a:t>Your student's practice session</a:t>
             </a:r>
           </a:p>
           <a:p>
             <a:pPr algn="ctr"/>
             <a:r>
-              <a:rPr sz="1400" b="0">
+              <a:rPr sz="1400" b="0" dirty="0">
                 <a:solidFill>
                   <a:srgbClr val="1A1A1A"/>
                 </a:solidFill>
                 <a:latin typeface="Calibri"/>
               </a:rPr>
-              <a:t>Your student's practice session</a:t>
-            </a:r>
+              <a:t>is your evidence.</a:t>
+            </a:r>
+            <a:endParaRPr lang="en-US" sz="1400" b="0" dirty="0">
+              <a:solidFill>
+                <a:srgbClr val="1A1A1A"/>
+              </a:solidFill>
+              <a:latin typeface="Calibri"/>
+            </a:endParaRPr>
           </a:p>
           <a:p>
             <a:pPr algn="ctr"/>
-            <a:r>
-              <a:rPr sz="1400" b="0">
+            <a:endParaRPr lang="en-US" sz="1400" dirty="0">
+              <a:solidFill>
+                <a:srgbClr val="1A1A1A"/>
+              </a:solidFill>
+              <a:latin typeface="Calibri"/>
+            </a:endParaRPr>
+          </a:p>
+          <a:p>
+            <a:pPr algn="ctr"/>
+            <a:r>
+              <a:rPr lang="en-US" sz="1400" dirty="0">
                 <a:solidFill>
                   <a:srgbClr val="1A1A1A"/>
                 </a:solidFill>
                 <a:latin typeface="Calibri"/>
               </a:rPr>
-              <a:t>is your evidence.</a:t>
-            </a:r>
+              <a:t>For you to</a:t>
+            </a:r>
+            <a:r>
+              <a:rPr lang="en-US" sz="1400" b="0" dirty="0">
+                <a:solidFill>
+                  <a:srgbClr val="1A1A1A"/>
+                </a:solidFill>
+                <a:latin typeface="Calibri"/>
+              </a:rPr>
+              <a:t> be certified by your teacher for successfully teaching anther person, your teacher must agree that your student has met your teacher’s standard.</a:t>
+            </a:r>
+            <a:endParaRPr sz="1400" b="0" dirty="0">
+              <a:solidFill>
+                <a:srgbClr val="1A1A1A"/>
+              </a:solidFill>
+              <a:latin typeface="Calibri"/>
+            </a:endParaRPr>
           </a:p>
         </p:txBody>
       </p:sp>
@@ -7955,7 +8248,7 @@
 </file>
 
 <file path=ppt/slides/slide5.xml><?xml version="1.0" encoding="utf-8"?>
-<p:sld xmlns:a="http://schemas.openxmlformats.org/drawingml/2006/main" xmlns:p="http://schemas.openxmlformats.org/presentationml/2006/main" xmlns:r="http://schemas.openxmlformats.org/officeDocument/2006/relationships">
+<p:sld xmlns:a="http://schemas.openxmlformats.org/drawingml/2006/main" xmlns:r="http://schemas.openxmlformats.org/officeDocument/2006/relationships" xmlns:p="http://schemas.openxmlformats.org/presentationml/2006/main">
   <p:cSld>
     <p:bg>
       <p:bgPr>
@@ -7971,7 +8264,14 @@
         <p:cNvGrpSpPr/>
         <p:nvPr/>
       </p:nvGrpSpPr>
-      <p:grpSpPr/>
+      <p:grpSpPr>
+        <a:xfrm>
+          <a:off x="0" y="0"/>
+          <a:ext cx="0" cy="0"/>
+          <a:chOff x="0" y="0"/>
+          <a:chExt cx="0" cy="0"/>
+        </a:xfrm>
+      </p:grpSpPr>
       <p:sp>
         <p:nvSpPr>
           <p:cNvPr id="2" name="TextBox 1"/>
@@ -8047,6 +8347,7 @@
           <a:lstStyle/>
           <a:p>
             <a:pPr algn="ctr"/>
+            <a:endParaRPr/>
           </a:p>
         </p:txBody>
       </p:sp>
@@ -8120,14 +8421,23 @@
           </a:p>
           <a:p>
             <a:pPr algn="l"/>
-            <a:r>
-              <a:rPr sz="800" b="0">
+            <a:endParaRPr sz="1800" b="1">
+              <a:solidFill>
+                <a:srgbClr val="1A1A1A"/>
+              </a:solidFill>
+              <a:latin typeface="Calibri"/>
+            </a:endParaRPr>
+          </a:p>
+          <a:p>
+            <a:pPr algn="l"/>
+            <a:r>
+              <a:rPr sz="1600" b="0">
                 <a:solidFill>
                   <a:srgbClr val="1A1A1A"/>
                 </a:solidFill>
                 <a:latin typeface="Calibri"/>
               </a:rPr>
-              <a:t/>
+              <a:t>  ·  The skill name and issuing NDC</a:t>
             </a:r>
           </a:p>
           <a:p>
@@ -8139,7 +8449,7 @@
                 </a:solidFill>
                 <a:latin typeface="Calibri"/>
               </a:rPr>
-              <a:t>  ·  The skill name and issuing NDC</a:t>
+              <a:t>  ·  When each gate was completed</a:t>
             </a:r>
           </a:p>
           <a:p>
@@ -8151,7 +8461,7 @@
                 </a:solidFill>
                 <a:latin typeface="Calibri"/>
               </a:rPr>
-              <a:t>  ·  When each gate was completed</a:t>
+              <a:t>  ·  Your mentor's name (clickable)</a:t>
             </a:r>
           </a:p>
           <a:p>
@@ -8163,7 +8473,7 @@
                 </a:solidFill>
                 <a:latin typeface="Calibri"/>
               </a:rPr>
-              <a:t>  ·  Your mentor's name (clickable)</a:t>
+              <a:t>  ·  The full attempt history</a:t>
             </a:r>
           </a:p>
           <a:p>
@@ -8175,32 +8485,17 @@
                 </a:solidFill>
                 <a:latin typeface="Calibri"/>
               </a:rPr>
-              <a:t>  ·  The full attempt history</a:t>
+              <a:t>  ·  A Verify button</a:t>
             </a:r>
           </a:p>
           <a:p>
             <a:pPr algn="l"/>
-            <a:r>
-              <a:rPr sz="1600" b="0">
-                <a:solidFill>
-                  <a:srgbClr val="1A1A1A"/>
-                </a:solidFill>
-                <a:latin typeface="Calibri"/>
-              </a:rPr>
-              <a:t>  ·  A Verify button</a:t>
-            </a:r>
-          </a:p>
-          <a:p>
-            <a:pPr algn="l"/>
-            <a:r>
-              <a:rPr sz="800" b="0">
-                <a:solidFill>
-                  <a:srgbClr val="1A1A1A"/>
-                </a:solidFill>
-                <a:latin typeface="Calibri"/>
-              </a:rPr>
-              <a:t/>
-            </a:r>
+            <a:endParaRPr sz="1600" b="0">
+              <a:solidFill>
+                <a:srgbClr val="1A1A1A"/>
+              </a:solidFill>
+              <a:latin typeface="Calibri"/>
+            </a:endParaRPr>
           </a:p>
           <a:p>
             <a:pPr algn="l"/>
@@ -8270,6 +8565,7 @@
           <a:lstStyle/>
           <a:p>
             <a:pPr algn="ctr"/>
+            <a:endParaRPr/>
           </a:p>
         </p:txBody>
       </p:sp>
@@ -8313,6 +8609,7 @@
           <a:lstStyle/>
           <a:p>
             <a:pPr algn="ctr"/>
+            <a:endParaRPr/>
           </a:p>
         </p:txBody>
       </p:sp>
@@ -8555,6 +8852,7 @@
           <a:lstStyle/>
           <a:p>
             <a:pPr algn="ctr"/>
+            <a:endParaRPr/>
           </a:p>
         </p:txBody>
       </p:sp>
@@ -8637,7 +8935,7 @@
 </file>
 
 <file path=ppt/slides/slide6.xml><?xml version="1.0" encoding="utf-8"?>
-<p:sld xmlns:a="http://schemas.openxmlformats.org/drawingml/2006/main" xmlns:p="http://schemas.openxmlformats.org/presentationml/2006/main" xmlns:r="http://schemas.openxmlformats.org/officeDocument/2006/relationships">
+<p:sld xmlns:a="http://schemas.openxmlformats.org/drawingml/2006/main" xmlns:r="http://schemas.openxmlformats.org/officeDocument/2006/relationships" xmlns:p="http://schemas.openxmlformats.org/presentationml/2006/main">
   <p:cSld>
     <p:bg>
       <p:bgPr>
@@ -8653,7 +8951,14 @@
         <p:cNvGrpSpPr/>
         <p:nvPr/>
       </p:nvGrpSpPr>
-      <p:grpSpPr/>
+      <p:grpSpPr>
+        <a:xfrm>
+          <a:off x="0" y="0"/>
+          <a:ext cx="0" cy="0"/>
+          <a:chOff x="0" y="0"/>
+          <a:chExt cx="0" cy="0"/>
+        </a:xfrm>
+      </p:grpSpPr>
       <p:sp>
         <p:nvSpPr>
           <p:cNvPr id="2" name="TextBox 1"/>
@@ -8729,6 +9034,7 @@
           <a:lstStyle/>
           <a:p>
             <a:pPr algn="ctr"/>
+            <a:endParaRPr/>
           </a:p>
         </p:txBody>
       </p:sp>
@@ -8807,6 +9113,7 @@
           <a:lstStyle/>
           <a:p>
             <a:pPr algn="ctr"/>
+            <a:endParaRPr/>
           </a:p>
         </p:txBody>
       </p:sp>
@@ -8990,6 +9297,7 @@
           <a:lstStyle/>
           <a:p>
             <a:pPr algn="ctr"/>
+            <a:endParaRPr/>
           </a:p>
         </p:txBody>
       </p:sp>
@@ -9173,6 +9481,7 @@
           <a:lstStyle/>
           <a:p>
             <a:pPr algn="ctr"/>
+            <a:endParaRPr/>
           </a:p>
         </p:txBody>
       </p:sp>
@@ -9251,6 +9560,7 @@
           <a:lstStyle/>
           <a:p>
             <a:pPr algn="ctr"/>
+            <a:endParaRPr/>
           </a:p>
         </p:txBody>
       </p:sp>
@@ -9329,6 +9639,7 @@
           <a:lstStyle/>
           <a:p>
             <a:pPr algn="ctr"/>
+            <a:endParaRPr/>
           </a:p>
         </p:txBody>
       </p:sp>
@@ -9407,6 +9718,7 @@
           <a:lstStyle/>
           <a:p>
             <a:pPr algn="ctr"/>
+            <a:endParaRPr/>
           </a:p>
         </p:txBody>
       </p:sp>
@@ -9485,6 +9797,7 @@
           <a:lstStyle/>
           <a:p>
             <a:pPr algn="ctr"/>
+            <a:endParaRPr/>
           </a:p>
         </p:txBody>
       </p:sp>
@@ -9600,6 +9913,7 @@
           <a:lstStyle/>
           <a:p>
             <a:pPr algn="ctr"/>
+            <a:endParaRPr/>
           </a:p>
         </p:txBody>
       </p:sp>
@@ -9682,7 +9996,7 @@
 </file>
 
 <file path=ppt/slides/slide7.xml><?xml version="1.0" encoding="utf-8"?>
-<p:sld xmlns:a="http://schemas.openxmlformats.org/drawingml/2006/main" xmlns:p="http://schemas.openxmlformats.org/presentationml/2006/main" xmlns:r="http://schemas.openxmlformats.org/officeDocument/2006/relationships">
+<p:sld xmlns:a="http://schemas.openxmlformats.org/drawingml/2006/main" xmlns:r="http://schemas.openxmlformats.org/officeDocument/2006/relationships" xmlns:p="http://schemas.openxmlformats.org/presentationml/2006/main">
   <p:cSld>
     <p:bg>
       <p:bgPr>
@@ -9698,7 +10012,14 @@
         <p:cNvGrpSpPr/>
         <p:nvPr/>
       </p:nvGrpSpPr>
-      <p:grpSpPr/>
+      <p:grpSpPr>
+        <a:xfrm>
+          <a:off x="0" y="0"/>
+          <a:ext cx="0" cy="0"/>
+          <a:chOff x="0" y="0"/>
+          <a:chExt cx="0" cy="0"/>
+        </a:xfrm>
+      </p:grpSpPr>
       <p:sp>
         <p:nvSpPr>
           <p:cNvPr id="2" name="TextBox 1"/>
@@ -9774,6 +10095,7 @@
           <a:lstStyle/>
           <a:p>
             <a:pPr algn="ctr"/>
+            <a:endParaRPr/>
           </a:p>
         </p:txBody>
       </p:sp>
@@ -9929,7 +10251,7 @@
 </file>
 
 <file path=ppt/slides/slide8.xml><?xml version="1.0" encoding="utf-8"?>
-<p:sld xmlns:a="http://schemas.openxmlformats.org/drawingml/2006/main" xmlns:p="http://schemas.openxmlformats.org/presentationml/2006/main" xmlns:r="http://schemas.openxmlformats.org/officeDocument/2006/relationships">
+<p:sld xmlns:a="http://schemas.openxmlformats.org/drawingml/2006/main" xmlns:r="http://schemas.openxmlformats.org/officeDocument/2006/relationships" xmlns:p="http://schemas.openxmlformats.org/presentationml/2006/main">
   <p:cSld>
     <p:bg>
       <p:bgPr>
@@ -9945,7 +10267,14 @@
         <p:cNvGrpSpPr/>
         <p:nvPr/>
       </p:nvGrpSpPr>
-      <p:grpSpPr/>
+      <p:grpSpPr>
+        <a:xfrm>
+          <a:off x="0" y="0"/>
+          <a:ext cx="0" cy="0"/>
+          <a:chOff x="0" y="0"/>
+          <a:chExt cx="0" cy="0"/>
+        </a:xfrm>
+      </p:grpSpPr>
       <p:sp>
         <p:nvSpPr>
           <p:cNvPr id="2" name="TextBox 1"/>
@@ -10021,6 +10350,7 @@
           <a:lstStyle/>
           <a:p>
             <a:pPr algn="ctr"/>
+            <a:endParaRPr/>
           </a:p>
         </p:txBody>
       </p:sp>
@@ -10033,7 +10363,7 @@
         <p:spPr>
           <a:xfrm>
             <a:off x="411480" y="566928"/>
-            <a:ext cx="11338560" cy="1188720"/>
+            <a:ext cx="11338560" cy="1138773"/>
           </a:xfrm>
           <a:prstGeom prst="rect">
             <a:avLst/>
@@ -10048,7 +10378,7 @@
           <a:p>
             <a:pPr algn="l"/>
             <a:r>
-              <a:rPr sz="3400" b="1" i="0">
+              <a:rPr sz="3400" b="1" i="0" dirty="0">
                 <a:solidFill>
                   <a:srgbClr val="1A1A1A"/>
                 </a:solidFill>
@@ -10056,6 +10386,33 @@
               </a:rPr>
               <a:t>8 Active Credentials · 23+ Skills Planned</a:t>
             </a:r>
+            <a:r>
+              <a:rPr lang="en-US" sz="3400" b="1" i="0" dirty="0">
+                <a:solidFill>
+                  <a:srgbClr val="1A1A1A"/>
+                </a:solidFill>
+                <a:latin typeface="Calibri"/>
+              </a:rPr>
+              <a:t> </a:t>
+            </a:r>
+          </a:p>
+          <a:p>
+            <a:pPr algn="l"/>
+            <a:r>
+              <a:rPr lang="en-US" sz="3400" b="1" i="0" dirty="0">
+                <a:solidFill>
+                  <a:srgbClr val="1A1A1A"/>
+                </a:solidFill>
+                <a:latin typeface="Calibri"/>
+              </a:rPr>
+              <a:t>(THIS PAGE IS NOT ACCURATE—DEMO ONLY)</a:t>
+            </a:r>
+            <a:endParaRPr sz="3400" b="1" i="0" dirty="0">
+              <a:solidFill>
+                <a:srgbClr val="1A1A1A"/>
+              </a:solidFill>
+              <a:latin typeface="Calibri"/>
+            </a:endParaRPr>
           </a:p>
         </p:txBody>
       </p:sp>
@@ -10099,6 +10456,7 @@
           <a:lstStyle/>
           <a:p>
             <a:pPr algn="ctr"/>
+            <a:endParaRPr/>
           </a:p>
         </p:txBody>
       </p:sp>
@@ -10231,7 +10589,7 @@
           <a:p>
             <a:pPr algn="l"/>
             <a:r>
-              <a:rPr sz="1500" b="0" i="0">
+              <a:rPr sz="1500" b="0" i="0" dirty="0">
                 <a:solidFill>
                   <a:srgbClr val="1A1A1A"/>
                 </a:solidFill>
@@ -10457,6 +10815,7 @@
           <a:lstStyle/>
           <a:p>
             <a:pPr algn="ctr"/>
+            <a:endParaRPr/>
           </a:p>
         </p:txBody>
       </p:sp>
@@ -10589,7 +10948,7 @@
           <a:p>
             <a:pPr algn="l"/>
             <a:r>
-              <a:rPr sz="1400" b="0" i="0">
+              <a:rPr sz="1400" b="0" i="0" dirty="0">
                 <a:solidFill>
                   <a:srgbClr val="475569"/>
                 </a:solidFill>
@@ -10850,6 +11209,7 @@
           <a:lstStyle/>
           <a:p>
             <a:pPr algn="ctr"/>
+            <a:endParaRPr/>
           </a:p>
         </p:txBody>
       </p:sp>
@@ -10862,7 +11222,7 @@
 </file>
 
 <file path=ppt/slides/slide9.xml><?xml version="1.0" encoding="utf-8"?>
-<p:sld xmlns:a="http://schemas.openxmlformats.org/drawingml/2006/main" xmlns:p="http://schemas.openxmlformats.org/presentationml/2006/main" xmlns:r="http://schemas.openxmlformats.org/officeDocument/2006/relationships">
+<p:sld xmlns:a="http://schemas.openxmlformats.org/drawingml/2006/main" xmlns:r="http://schemas.openxmlformats.org/officeDocument/2006/relationships" xmlns:p="http://schemas.openxmlformats.org/presentationml/2006/main">
   <p:cSld>
     <p:bg>
       <p:bgPr>
@@ -10878,7 +11238,14 @@
         <p:cNvGrpSpPr/>
         <p:nvPr/>
       </p:nvGrpSpPr>
-      <p:grpSpPr/>
+      <p:grpSpPr>
+        <a:xfrm>
+          <a:off x="0" y="0"/>
+          <a:ext cx="0" cy="0"/>
+          <a:chOff x="0" y="0"/>
+          <a:chExt cx="0" cy="0"/>
+        </a:xfrm>
+      </p:grpSpPr>
       <p:sp>
         <p:nvSpPr>
           <p:cNvPr id="2" name="TextBox 1"/>
@@ -10888,7 +11255,7 @@
         <p:spPr>
           <a:xfrm>
             <a:off x="731520" y="914400"/>
-            <a:ext cx="10698480" cy="2011680"/>
+            <a:ext cx="10698480" cy="615553"/>
           </a:xfrm>
           <a:prstGeom prst="rect">
             <a:avLst/>
@@ -10903,15 +11270,101 @@
           <a:p>
             <a:pPr algn="ctr"/>
             <a:r>
-              <a:rPr sz="3400" b="1" i="0">
+              <a:rPr lang="en-US" sz="3400" b="1" i="0" dirty="0">
                 <a:solidFill>
                   <a:srgbClr val="FFFFFF"/>
                 </a:solidFill>
                 <a:latin typeface="Calibri"/>
               </a:rPr>
-              <a:t>"A credential without an economy
-is just a piece of paper."</a:t>
-            </a:r>
+              <a:t>Thes</a:t>
+            </a:r>
+            <a:r>
+              <a:rPr lang="en-US" sz="3400" b="1" dirty="0">
+                <a:solidFill>
+                  <a:srgbClr val="FFFFFF"/>
+                </a:solidFill>
+                <a:latin typeface="Calibri"/>
+              </a:rPr>
+              <a:t>e c</a:t>
+            </a:r>
+            <a:r>
+              <a:rPr sz="3400" b="1" i="0" dirty="0">
+                <a:solidFill>
+                  <a:srgbClr val="FFFFFF"/>
+                </a:solidFill>
+                <a:latin typeface="Calibri"/>
+              </a:rPr>
+              <a:t>redential</a:t>
+            </a:r>
+            <a:r>
+              <a:rPr lang="en-US" sz="3400" b="1" i="0" dirty="0">
+                <a:solidFill>
+                  <a:srgbClr val="FFFFFF"/>
+                </a:solidFill>
+                <a:latin typeface="Calibri"/>
+              </a:rPr>
+              <a:t>s</a:t>
+            </a:r>
+            <a:r>
+              <a:rPr sz="3400" b="1" i="0" dirty="0">
+                <a:solidFill>
+                  <a:srgbClr val="FFFFFF"/>
+                </a:solidFill>
+                <a:latin typeface="Calibri"/>
+              </a:rPr>
+              <a:t> </a:t>
+            </a:r>
+            <a:r>
+              <a:rPr lang="en-US" sz="3400" b="1" i="0" dirty="0">
+                <a:solidFill>
+                  <a:srgbClr val="FFFFFF"/>
+                </a:solidFill>
+                <a:latin typeface="Calibri"/>
+              </a:rPr>
+              <a:t>encourage</a:t>
+            </a:r>
+            <a:r>
+              <a:rPr sz="3400" b="1" i="0" dirty="0">
+                <a:solidFill>
+                  <a:srgbClr val="FFFFFF"/>
+                </a:solidFill>
+                <a:latin typeface="Calibri"/>
+              </a:rPr>
+              <a:t>  </a:t>
+            </a:r>
+            <a:r>
+              <a:rPr lang="en-US" sz="3400" b="1" i="0" dirty="0">
+                <a:solidFill>
+                  <a:srgbClr val="FFFFFF"/>
+                </a:solidFill>
+                <a:latin typeface="Calibri"/>
+              </a:rPr>
+              <a:t>local trading </a:t>
+            </a:r>
+            <a:r>
+              <a:rPr sz="3400" b="1" i="0" dirty="0">
+                <a:solidFill>
+                  <a:srgbClr val="FFFFFF"/>
+                </a:solidFill>
+                <a:latin typeface="Calibri"/>
+              </a:rPr>
+              <a:t>econom</a:t>
+            </a:r>
+            <a:r>
+              <a:rPr lang="en-US" sz="3400" b="1" i="0" dirty="0">
+                <a:solidFill>
+                  <a:srgbClr val="FFFFFF"/>
+                </a:solidFill>
+                <a:latin typeface="Calibri"/>
+              </a:rPr>
+              <a:t>ies.</a:t>
+            </a:r>
+            <a:endParaRPr sz="3400" b="1" i="0" dirty="0">
+              <a:solidFill>
+                <a:srgbClr val="FFFFFF"/>
+              </a:solidFill>
+              <a:latin typeface="Calibri"/>
+            </a:endParaRPr>
           </a:p>
         </p:txBody>
       </p:sp>
@@ -10955,6 +11408,7 @@
           <a:lstStyle/>
           <a:p>
             <a:pPr algn="ctr"/>
+            <a:endParaRPr/>
           </a:p>
         </p:txBody>
       </p:sp>

</xml_diff>